<commit_message>
Ghi IP va User-Agent vao phien thiet bi luc dang nhap
- DeviceSession them ip + userAgent; hien trong khay thiet bi dang nhap
- Giup phan biet 2 may cung nhan 'Chrome - Windows' va truy vet nguon vao

Generated with [Devin](https://devin.ai)

Co-Authored-By: Devin <158243242+devin-ai-integration[bot]@users.noreply.github.com>
</commit_message>
<xml_diff>
--- a/LeHongLinh_Slides.pptx
+++ b/LeHongLinh_Slides.pptx
@@ -5,23 +5,23 @@
     <p:sldMasterId id="2147483648" r:id="rId1"/>
   </p:sldMasterIdLst>
   <p:sldIdLst>
-    <p:sldId id="256" r:id="rId7"/>
-    <p:sldId id="257" r:id="rId8"/>
-    <p:sldId id="258" r:id="rId9"/>
-    <p:sldId id="259" r:id="rId10"/>
-    <p:sldId id="260" r:id="rId11"/>
-    <p:sldId id="261" r:id="rId12"/>
-    <p:sldId id="262" r:id="rId13"/>
-    <p:sldId id="263" r:id="rId14"/>
-    <p:sldId id="264" r:id="rId15"/>
-    <p:sldId id="265" r:id="rId16"/>
-    <p:sldId id="266" r:id="rId17"/>
-    <p:sldId id="267" r:id="rId18"/>
-    <p:sldId id="268" r:id="rId19"/>
-    <p:sldId id="269" r:id="rId20"/>
-    <p:sldId id="270" r:id="rId21"/>
+    <p:sldId id="256" r:id="rId2"/>
+    <p:sldId id="257" r:id="rId3"/>
+    <p:sldId id="258" r:id="rId4"/>
+    <p:sldId id="259" r:id="rId5"/>
+    <p:sldId id="260" r:id="rId6"/>
+    <p:sldId id="261" r:id="rId7"/>
+    <p:sldId id="262" r:id="rId8"/>
+    <p:sldId id="263" r:id="rId9"/>
+    <p:sldId id="264" r:id="rId10"/>
+    <p:sldId id="265" r:id="rId11"/>
+    <p:sldId id="266" r:id="rId12"/>
+    <p:sldId id="267" r:id="rId13"/>
+    <p:sldId id="268" r:id="rId14"/>
+    <p:sldId id="269" r:id="rId15"/>
+    <p:sldId id="270" r:id="rId16"/>
   </p:sldIdLst>
-  <p:sldSz cx="12192000" cy="6858000" type="screen4x3"/>
+  <p:sldSz cx="12192000" cy="6858000"/>
   <p:notesSz cx="6858000" cy="9144000"/>
   <p:defaultTextStyle>
     <a:defPPr>
@@ -118,6 +118,22 @@
       </a:defRPr>
     </a:lvl9pPr>
   </p:defaultTextStyle>
+  <p:extLst>
+    <p:ext uri="{EFAFB233-063F-42B5-8137-9DF3F51BA10A}">
+      <p15:sldGuideLst xmlns:p15="http://schemas.microsoft.com/office/powerpoint/2012/main">
+        <p15:guide id="1" orient="horz" pos="2160">
+          <p15:clr>
+            <a:srgbClr val="A4A3A4"/>
+          </p15:clr>
+        </p15:guide>
+        <p15:guide id="2" pos="2880">
+          <p15:clr>
+            <a:srgbClr val="A4A3A4"/>
+          </p15:clr>
+        </p15:guide>
+      </p15:sldGuideLst>
+    </p:ext>
+  </p:extLst>
 </p:presentation>
 </file>
 
@@ -159,10 +175,9 @@
           <a:lstStyle/>
           <a:p>
             <a:r>
-              <a:rPr lang="en-US" smtClean="0"/>
+              <a:rPr lang="en-US"/>
               <a:t>Click to edit Master title style</a:t>
             </a:r>
-            <a:endParaRPr lang="en-US"/>
           </a:p>
         </p:txBody>
       </p:sp>
@@ -278,10 +293,9 @@
           </a:lstStyle>
           <a:p>
             <a:r>
-              <a:rPr lang="en-US" smtClean="0"/>
+              <a:rPr lang="en-US"/>
               <a:t>Click to edit Master subtitle style</a:t>
             </a:r>
-            <a:endParaRPr lang="en-US"/>
           </a:p>
         </p:txBody>
       </p:sp>
@@ -302,7 +316,7 @@
           <a:p>
             <a:fld id="{5BCAD085-E8A6-8845-BD4E-CB4CCA059FC4}" type="datetimeFigureOut">
               <a:rPr lang="en-US" smtClean="0"/>
-              <a:t>1/27/13</a:t>
+              <a:t>10/12/2026</a:t>
             </a:fld>
             <a:endParaRPr lang="en-US"/>
           </a:p>
@@ -396,10 +410,9 @@
           <a:lstStyle/>
           <a:p>
             <a:r>
-              <a:rPr lang="en-US" smtClean="0"/>
+              <a:rPr lang="en-US"/>
               <a:t>Click to edit Master title style</a:t>
             </a:r>
-            <a:endParaRPr lang="en-US"/>
           </a:p>
         </p:txBody>
       </p:sp>
@@ -420,38 +433,37 @@
           <a:p>
             <a:pPr lvl="0"/>
             <a:r>
-              <a:rPr lang="en-US" smtClean="0"/>
+              <a:rPr lang="en-US"/>
               <a:t>Click to edit Master text styles</a:t>
             </a:r>
           </a:p>
           <a:p>
             <a:pPr lvl="1"/>
             <a:r>
-              <a:rPr lang="en-US" smtClean="0"/>
+              <a:rPr lang="en-US"/>
               <a:t>Second level</a:t>
             </a:r>
           </a:p>
           <a:p>
             <a:pPr lvl="2"/>
             <a:r>
-              <a:rPr lang="en-US" smtClean="0"/>
+              <a:rPr lang="en-US"/>
               <a:t>Third level</a:t>
             </a:r>
           </a:p>
           <a:p>
             <a:pPr lvl="3"/>
             <a:r>
-              <a:rPr lang="en-US" smtClean="0"/>
+              <a:rPr lang="en-US"/>
               <a:t>Fourth level</a:t>
             </a:r>
           </a:p>
           <a:p>
             <a:pPr lvl="4"/>
             <a:r>
-              <a:rPr lang="en-US" smtClean="0"/>
+              <a:rPr lang="en-US"/>
               <a:t>Fifth level</a:t>
             </a:r>
-            <a:endParaRPr lang="en-US"/>
           </a:p>
         </p:txBody>
       </p:sp>
@@ -472,7 +484,7 @@
           <a:p>
             <a:fld id="{5BCAD085-E8A6-8845-BD4E-CB4CCA059FC4}" type="datetimeFigureOut">
               <a:rPr lang="en-US" smtClean="0"/>
-              <a:t>1/27/13</a:t>
+              <a:t>10/12/2026</a:t>
             </a:fld>
             <a:endParaRPr lang="en-US"/>
           </a:p>
@@ -571,10 +583,9 @@
           <a:lstStyle/>
           <a:p>
             <a:r>
-              <a:rPr lang="en-US" smtClean="0"/>
+              <a:rPr lang="en-US"/>
               <a:t>Click to edit Master title style</a:t>
             </a:r>
-            <a:endParaRPr lang="en-US"/>
           </a:p>
         </p:txBody>
       </p:sp>
@@ -600,38 +611,37 @@
           <a:p>
             <a:pPr lvl="0"/>
             <a:r>
-              <a:rPr lang="en-US" smtClean="0"/>
+              <a:rPr lang="en-US"/>
               <a:t>Click to edit Master text styles</a:t>
             </a:r>
           </a:p>
           <a:p>
             <a:pPr lvl="1"/>
             <a:r>
-              <a:rPr lang="en-US" smtClean="0"/>
+              <a:rPr lang="en-US"/>
               <a:t>Second level</a:t>
             </a:r>
           </a:p>
           <a:p>
             <a:pPr lvl="2"/>
             <a:r>
-              <a:rPr lang="en-US" smtClean="0"/>
+              <a:rPr lang="en-US"/>
               <a:t>Third level</a:t>
             </a:r>
           </a:p>
           <a:p>
             <a:pPr lvl="3"/>
             <a:r>
-              <a:rPr lang="en-US" smtClean="0"/>
+              <a:rPr lang="en-US"/>
               <a:t>Fourth level</a:t>
             </a:r>
           </a:p>
           <a:p>
             <a:pPr lvl="4"/>
             <a:r>
-              <a:rPr lang="en-US" smtClean="0"/>
+              <a:rPr lang="en-US"/>
               <a:t>Fifth level</a:t>
             </a:r>
-            <a:endParaRPr lang="en-US"/>
           </a:p>
         </p:txBody>
       </p:sp>
@@ -652,7 +662,7 @@
           <a:p>
             <a:fld id="{5BCAD085-E8A6-8845-BD4E-CB4CCA059FC4}" type="datetimeFigureOut">
               <a:rPr lang="en-US" smtClean="0"/>
-              <a:t>1/27/13</a:t>
+              <a:t>10/12/2026</a:t>
             </a:fld>
             <a:endParaRPr lang="en-US"/>
           </a:p>
@@ -746,10 +756,9 @@
           <a:lstStyle/>
           <a:p>
             <a:r>
-              <a:rPr lang="en-US" smtClean="0"/>
+              <a:rPr lang="en-US"/>
               <a:t>Click to edit Master title style</a:t>
             </a:r>
-            <a:endParaRPr lang="en-US"/>
           </a:p>
         </p:txBody>
       </p:sp>
@@ -770,38 +779,37 @@
           <a:p>
             <a:pPr lvl="0"/>
             <a:r>
-              <a:rPr lang="en-US" smtClean="0"/>
+              <a:rPr lang="en-US"/>
               <a:t>Click to edit Master text styles</a:t>
             </a:r>
           </a:p>
           <a:p>
             <a:pPr lvl="1"/>
             <a:r>
-              <a:rPr lang="en-US" smtClean="0"/>
+              <a:rPr lang="en-US"/>
               <a:t>Second level</a:t>
             </a:r>
           </a:p>
           <a:p>
             <a:pPr lvl="2"/>
             <a:r>
-              <a:rPr lang="en-US" smtClean="0"/>
+              <a:rPr lang="en-US"/>
               <a:t>Third level</a:t>
             </a:r>
           </a:p>
           <a:p>
             <a:pPr lvl="3"/>
             <a:r>
-              <a:rPr lang="en-US" smtClean="0"/>
+              <a:rPr lang="en-US"/>
               <a:t>Fourth level</a:t>
             </a:r>
           </a:p>
           <a:p>
             <a:pPr lvl="4"/>
             <a:r>
-              <a:rPr lang="en-US" smtClean="0"/>
+              <a:rPr lang="en-US"/>
               <a:t>Fifth level</a:t>
             </a:r>
-            <a:endParaRPr lang="en-US"/>
           </a:p>
         </p:txBody>
       </p:sp>
@@ -822,7 +830,7 @@
           <a:p>
             <a:fld id="{5BCAD085-E8A6-8845-BD4E-CB4CCA059FC4}" type="datetimeFigureOut">
               <a:rPr lang="en-US" smtClean="0"/>
-              <a:t>1/27/13</a:t>
+              <a:t>10/12/2026</a:t>
             </a:fld>
             <a:endParaRPr lang="en-US"/>
           </a:p>
@@ -925,10 +933,9 @@
           </a:lstStyle>
           <a:p>
             <a:r>
-              <a:rPr lang="en-US" smtClean="0"/>
+              <a:rPr lang="en-US"/>
               <a:t>Click to edit Master title style</a:t>
             </a:r>
-            <a:endParaRPr lang="en-US"/>
           </a:p>
         </p:txBody>
       </p:sp>
@@ -1045,7 +1052,7 @@
           <a:p>
             <a:pPr lvl="0"/>
             <a:r>
-              <a:rPr lang="en-US" smtClean="0"/>
+              <a:rPr lang="en-US"/>
               <a:t>Click to edit Master text styles</a:t>
             </a:r>
           </a:p>
@@ -1068,7 +1075,7 @@
           <a:p>
             <a:fld id="{5BCAD085-E8A6-8845-BD4E-CB4CCA059FC4}" type="datetimeFigureOut">
               <a:rPr lang="en-US" smtClean="0"/>
-              <a:t>1/27/13</a:t>
+              <a:t>10/12/2026</a:t>
             </a:fld>
             <a:endParaRPr lang="en-US"/>
           </a:p>
@@ -1162,10 +1169,9 @@
           <a:lstStyle/>
           <a:p>
             <a:r>
-              <a:rPr lang="en-US" smtClean="0"/>
+              <a:rPr lang="en-US"/>
               <a:t>Click to edit Master title style</a:t>
             </a:r>
-            <a:endParaRPr lang="en-US"/>
           </a:p>
         </p:txBody>
       </p:sp>
@@ -1219,38 +1225,37 @@
           <a:p>
             <a:pPr lvl="0"/>
             <a:r>
-              <a:rPr lang="en-US" smtClean="0"/>
+              <a:rPr lang="en-US"/>
               <a:t>Click to edit Master text styles</a:t>
             </a:r>
           </a:p>
           <a:p>
             <a:pPr lvl="1"/>
             <a:r>
-              <a:rPr lang="en-US" smtClean="0"/>
+              <a:rPr lang="en-US"/>
               <a:t>Second level</a:t>
             </a:r>
           </a:p>
           <a:p>
             <a:pPr lvl="2"/>
             <a:r>
-              <a:rPr lang="en-US" smtClean="0"/>
+              <a:rPr lang="en-US"/>
               <a:t>Third level</a:t>
             </a:r>
           </a:p>
           <a:p>
             <a:pPr lvl="3"/>
             <a:r>
-              <a:rPr lang="en-US" smtClean="0"/>
+              <a:rPr lang="en-US"/>
               <a:t>Fourth level</a:t>
             </a:r>
           </a:p>
           <a:p>
             <a:pPr lvl="4"/>
             <a:r>
-              <a:rPr lang="en-US" smtClean="0"/>
+              <a:rPr lang="en-US"/>
               <a:t>Fifth level</a:t>
             </a:r>
-            <a:endParaRPr lang="en-US"/>
           </a:p>
         </p:txBody>
       </p:sp>
@@ -1304,38 +1309,37 @@
           <a:p>
             <a:pPr lvl="0"/>
             <a:r>
-              <a:rPr lang="en-US" smtClean="0"/>
+              <a:rPr lang="en-US"/>
               <a:t>Click to edit Master text styles</a:t>
             </a:r>
           </a:p>
           <a:p>
             <a:pPr lvl="1"/>
             <a:r>
-              <a:rPr lang="en-US" smtClean="0"/>
+              <a:rPr lang="en-US"/>
               <a:t>Second level</a:t>
             </a:r>
           </a:p>
           <a:p>
             <a:pPr lvl="2"/>
             <a:r>
-              <a:rPr lang="en-US" smtClean="0"/>
+              <a:rPr lang="en-US"/>
               <a:t>Third level</a:t>
             </a:r>
           </a:p>
           <a:p>
             <a:pPr lvl="3"/>
             <a:r>
-              <a:rPr lang="en-US" smtClean="0"/>
+              <a:rPr lang="en-US"/>
               <a:t>Fourth level</a:t>
             </a:r>
           </a:p>
           <a:p>
             <a:pPr lvl="4"/>
             <a:r>
-              <a:rPr lang="en-US" smtClean="0"/>
+              <a:rPr lang="en-US"/>
               <a:t>Fifth level</a:t>
             </a:r>
-            <a:endParaRPr lang="en-US"/>
           </a:p>
         </p:txBody>
       </p:sp>
@@ -1356,7 +1360,7 @@
           <a:p>
             <a:fld id="{5BCAD085-E8A6-8845-BD4E-CB4CCA059FC4}" type="datetimeFigureOut">
               <a:rPr lang="en-US" smtClean="0"/>
-              <a:t>1/27/13</a:t>
+              <a:t>10/12/2026</a:t>
             </a:fld>
             <a:endParaRPr lang="en-US"/>
           </a:p>
@@ -1454,10 +1458,9 @@
           </a:lstStyle>
           <a:p>
             <a:r>
-              <a:rPr lang="en-US" smtClean="0"/>
+              <a:rPr lang="en-US"/>
               <a:t>Click to edit Master title style</a:t>
             </a:r>
-            <a:endParaRPr lang="en-US"/>
           </a:p>
         </p:txBody>
       </p:sp>
@@ -1520,7 +1523,7 @@
           <a:p>
             <a:pPr lvl="0"/>
             <a:r>
-              <a:rPr lang="en-US" smtClean="0"/>
+              <a:rPr lang="en-US"/>
               <a:t>Click to edit Master text styles</a:t>
             </a:r>
           </a:p>
@@ -1576,38 +1579,37 @@
           <a:p>
             <a:pPr lvl="0"/>
             <a:r>
-              <a:rPr lang="en-US" smtClean="0"/>
+              <a:rPr lang="en-US"/>
               <a:t>Click to edit Master text styles</a:t>
             </a:r>
           </a:p>
           <a:p>
             <a:pPr lvl="1"/>
             <a:r>
-              <a:rPr lang="en-US" smtClean="0"/>
+              <a:rPr lang="en-US"/>
               <a:t>Second level</a:t>
             </a:r>
           </a:p>
           <a:p>
             <a:pPr lvl="2"/>
             <a:r>
-              <a:rPr lang="en-US" smtClean="0"/>
+              <a:rPr lang="en-US"/>
               <a:t>Third level</a:t>
             </a:r>
           </a:p>
           <a:p>
             <a:pPr lvl="3"/>
             <a:r>
-              <a:rPr lang="en-US" smtClean="0"/>
+              <a:rPr lang="en-US"/>
               <a:t>Fourth level</a:t>
             </a:r>
           </a:p>
           <a:p>
             <a:pPr lvl="4"/>
             <a:r>
-              <a:rPr lang="en-US" smtClean="0"/>
+              <a:rPr lang="en-US"/>
               <a:t>Fifth level</a:t>
             </a:r>
-            <a:endParaRPr lang="en-US"/>
           </a:p>
         </p:txBody>
       </p:sp>
@@ -1670,7 +1672,7 @@
           <a:p>
             <a:pPr lvl="0"/>
             <a:r>
-              <a:rPr lang="en-US" smtClean="0"/>
+              <a:rPr lang="en-US"/>
               <a:t>Click to edit Master text styles</a:t>
             </a:r>
           </a:p>
@@ -1726,38 +1728,37 @@
           <a:p>
             <a:pPr lvl="0"/>
             <a:r>
-              <a:rPr lang="en-US" smtClean="0"/>
+              <a:rPr lang="en-US"/>
               <a:t>Click to edit Master text styles</a:t>
             </a:r>
           </a:p>
           <a:p>
             <a:pPr lvl="1"/>
             <a:r>
-              <a:rPr lang="en-US" smtClean="0"/>
+              <a:rPr lang="en-US"/>
               <a:t>Second level</a:t>
             </a:r>
           </a:p>
           <a:p>
             <a:pPr lvl="2"/>
             <a:r>
-              <a:rPr lang="en-US" smtClean="0"/>
+              <a:rPr lang="en-US"/>
               <a:t>Third level</a:t>
             </a:r>
           </a:p>
           <a:p>
             <a:pPr lvl="3"/>
             <a:r>
-              <a:rPr lang="en-US" smtClean="0"/>
+              <a:rPr lang="en-US"/>
               <a:t>Fourth level</a:t>
             </a:r>
           </a:p>
           <a:p>
             <a:pPr lvl="4"/>
             <a:r>
-              <a:rPr lang="en-US" smtClean="0"/>
+              <a:rPr lang="en-US"/>
               <a:t>Fifth level</a:t>
             </a:r>
-            <a:endParaRPr lang="en-US"/>
           </a:p>
         </p:txBody>
       </p:sp>
@@ -1778,7 +1779,7 @@
           <a:p>
             <a:fld id="{5BCAD085-E8A6-8845-BD4E-CB4CCA059FC4}" type="datetimeFigureOut">
               <a:rPr lang="en-US" smtClean="0"/>
-              <a:t>1/27/13</a:t>
+              <a:t>10/12/2026</a:t>
             </a:fld>
             <a:endParaRPr lang="en-US"/>
           </a:p>
@@ -1872,10 +1873,9 @@
           <a:lstStyle/>
           <a:p>
             <a:r>
-              <a:rPr lang="en-US" smtClean="0"/>
+              <a:rPr lang="en-US"/>
               <a:t>Click to edit Master title style</a:t>
             </a:r>
-            <a:endParaRPr lang="en-US"/>
           </a:p>
         </p:txBody>
       </p:sp>
@@ -1896,7 +1896,7 @@
           <a:p>
             <a:fld id="{5BCAD085-E8A6-8845-BD4E-CB4CCA059FC4}" type="datetimeFigureOut">
               <a:rPr lang="en-US" smtClean="0"/>
-              <a:t>1/27/13</a:t>
+              <a:t>10/12/2026</a:t>
             </a:fld>
             <a:endParaRPr lang="en-US"/>
           </a:p>
@@ -1991,7 +1991,7 @@
           <a:p>
             <a:fld id="{5BCAD085-E8A6-8845-BD4E-CB4CCA059FC4}" type="datetimeFigureOut">
               <a:rPr lang="en-US" smtClean="0"/>
-              <a:t>1/27/13</a:t>
+              <a:t>10/12/2026</a:t>
             </a:fld>
             <a:endParaRPr lang="en-US"/>
           </a:p>
@@ -2094,10 +2094,9 @@
           </a:lstStyle>
           <a:p>
             <a:r>
-              <a:rPr lang="en-US" smtClean="0"/>
+              <a:rPr lang="en-US"/>
               <a:t>Click to edit Master title style</a:t>
             </a:r>
-            <a:endParaRPr lang="en-US"/>
           </a:p>
         </p:txBody>
       </p:sp>
@@ -2151,38 +2150,37 @@
           <a:p>
             <a:pPr lvl="0"/>
             <a:r>
-              <a:rPr lang="en-US" smtClean="0"/>
+              <a:rPr lang="en-US"/>
               <a:t>Click to edit Master text styles</a:t>
             </a:r>
           </a:p>
           <a:p>
             <a:pPr lvl="1"/>
             <a:r>
-              <a:rPr lang="en-US" smtClean="0"/>
+              <a:rPr lang="en-US"/>
               <a:t>Second level</a:t>
             </a:r>
           </a:p>
           <a:p>
             <a:pPr lvl="2"/>
             <a:r>
-              <a:rPr lang="en-US" smtClean="0"/>
+              <a:rPr lang="en-US"/>
               <a:t>Third level</a:t>
             </a:r>
           </a:p>
           <a:p>
             <a:pPr lvl="3"/>
             <a:r>
-              <a:rPr lang="en-US" smtClean="0"/>
+              <a:rPr lang="en-US"/>
               <a:t>Fourth level</a:t>
             </a:r>
           </a:p>
           <a:p>
             <a:pPr lvl="4"/>
             <a:r>
-              <a:rPr lang="en-US" smtClean="0"/>
+              <a:rPr lang="en-US"/>
               <a:t>Fifth level</a:t>
             </a:r>
-            <a:endParaRPr lang="en-US"/>
           </a:p>
         </p:txBody>
       </p:sp>
@@ -2245,7 +2243,7 @@
           <a:p>
             <a:pPr lvl="0"/>
             <a:r>
-              <a:rPr lang="en-US" smtClean="0"/>
+              <a:rPr lang="en-US"/>
               <a:t>Click to edit Master text styles</a:t>
             </a:r>
           </a:p>
@@ -2268,7 +2266,7 @@
           <a:p>
             <a:fld id="{5BCAD085-E8A6-8845-BD4E-CB4CCA059FC4}" type="datetimeFigureOut">
               <a:rPr lang="en-US" smtClean="0"/>
-              <a:t>1/27/13</a:t>
+              <a:t>10/12/2026</a:t>
             </a:fld>
             <a:endParaRPr lang="en-US"/>
           </a:p>
@@ -2371,10 +2369,9 @@
           </a:lstStyle>
           <a:p>
             <a:r>
-              <a:rPr lang="en-US" smtClean="0"/>
+              <a:rPr lang="en-US"/>
               <a:t>Click to edit Master title style</a:t>
             </a:r>
-            <a:endParaRPr lang="en-US"/>
           </a:p>
         </p:txBody>
       </p:sp>
@@ -2498,7 +2495,7 @@
           <a:p>
             <a:pPr lvl="0"/>
             <a:r>
-              <a:rPr lang="en-US" smtClean="0"/>
+              <a:rPr lang="en-US"/>
               <a:t>Click to edit Master text styles</a:t>
             </a:r>
           </a:p>
@@ -2521,7 +2518,7 @@
           <a:p>
             <a:fld id="{5BCAD085-E8A6-8845-BD4E-CB4CCA059FC4}" type="datetimeFigureOut">
               <a:rPr lang="en-US" smtClean="0"/>
-              <a:t>1/27/13</a:t>
+              <a:t>10/12/2026</a:t>
             </a:fld>
             <a:endParaRPr lang="en-US"/>
           </a:p>
@@ -2630,10 +2627,9 @@
           <a:lstStyle/>
           <a:p>
             <a:r>
-              <a:rPr lang="en-US" smtClean="0"/>
+              <a:rPr lang="en-US"/>
               <a:t>Click to edit Master title style</a:t>
             </a:r>
-            <a:endParaRPr lang="en-US"/>
           </a:p>
         </p:txBody>
       </p:sp>
@@ -2664,38 +2660,37 @@
           <a:p>
             <a:pPr lvl="0"/>
             <a:r>
-              <a:rPr lang="en-US" smtClean="0"/>
+              <a:rPr lang="en-US"/>
               <a:t>Click to edit Master text styles</a:t>
             </a:r>
           </a:p>
           <a:p>
             <a:pPr lvl="1"/>
             <a:r>
-              <a:rPr lang="en-US" smtClean="0"/>
+              <a:rPr lang="en-US"/>
               <a:t>Second level</a:t>
             </a:r>
           </a:p>
           <a:p>
             <a:pPr lvl="2"/>
             <a:r>
-              <a:rPr lang="en-US" smtClean="0"/>
+              <a:rPr lang="en-US"/>
               <a:t>Third level</a:t>
             </a:r>
           </a:p>
           <a:p>
             <a:pPr lvl="3"/>
             <a:r>
-              <a:rPr lang="en-US" smtClean="0"/>
+              <a:rPr lang="en-US"/>
               <a:t>Fourth level</a:t>
             </a:r>
           </a:p>
           <a:p>
             <a:pPr lvl="4"/>
             <a:r>
-              <a:rPr lang="en-US" smtClean="0"/>
+              <a:rPr lang="en-US"/>
               <a:t>Fifth level</a:t>
             </a:r>
-            <a:endParaRPr lang="en-US"/>
           </a:p>
         </p:txBody>
       </p:sp>
@@ -2734,7 +2729,7 @@
           <a:p>
             <a:fld id="{5BCAD085-E8A6-8845-BD4E-CB4CCA059FC4}" type="datetimeFigureOut">
               <a:rPr lang="en-US" smtClean="0"/>
-              <a:t>1/27/13</a:t>
+              <a:t>10/12/2026</a:t>
             </a:fld>
             <a:endParaRPr lang="en-US"/>
           </a:p>
@@ -3093,7 +3088,7 @@
 </file>
 
 <file path=ppt/slides/slide1.xml><?xml version="1.0" encoding="utf-8"?>
-<p:sld xmlns:a="http://schemas.openxmlformats.org/drawingml/2006/main" xmlns:p="http://schemas.openxmlformats.org/presentationml/2006/main" xmlns:r="http://schemas.openxmlformats.org/officeDocument/2006/relationships">
+<p:sld xmlns:a="http://schemas.openxmlformats.org/drawingml/2006/main" xmlns:r="http://schemas.openxmlformats.org/officeDocument/2006/relationships" xmlns:p="http://schemas.openxmlformats.org/presentationml/2006/main">
   <p:cSld>
     <p:spTree>
       <p:nvGrpSpPr>
@@ -3101,7 +3096,14 @@
         <p:cNvGrpSpPr/>
         <p:nvPr/>
       </p:nvGrpSpPr>
-      <p:grpSpPr/>
+      <p:grpSpPr>
+        <a:xfrm>
+          <a:off x="0" y="0"/>
+          <a:ext cx="0" cy="0"/>
+          <a:chOff x="0" y="0"/>
+          <a:chExt cx="0" cy="0"/>
+        </a:xfrm>
+      </p:grpSpPr>
       <p:sp>
         <p:nvSpPr>
           <p:cNvPr id="2" name="Rectangle 1"/>
@@ -3143,6 +3145,7 @@
           <a:lstStyle/>
           <a:p>
             <a:pPr algn="ctr"/>
+            <a:endParaRPr/>
           </a:p>
         </p:txBody>
       </p:sp>
@@ -3187,6 +3190,7 @@
           <a:lstStyle/>
           <a:p>
             <a:pPr algn="ctr"/>
+            <a:endParaRPr/>
           </a:p>
         </p:txBody>
       </p:sp>
@@ -3290,6 +3294,7 @@
           <a:lstStyle/>
           <a:p>
             <a:pPr algn="ctr"/>
+            <a:endParaRPr/>
           </a:p>
         </p:txBody>
       </p:sp>
@@ -3451,6 +3456,7 @@
           <a:lstStyle/>
           <a:p>
             <a:pPr algn="ctr"/>
+            <a:endParaRPr/>
           </a:p>
         </p:txBody>
       </p:sp>
@@ -3463,7 +3469,7 @@
 </file>
 
 <file path=ppt/slides/slide10.xml><?xml version="1.0" encoding="utf-8"?>
-<p:sld xmlns:a="http://schemas.openxmlformats.org/drawingml/2006/main" xmlns:p="http://schemas.openxmlformats.org/presentationml/2006/main" xmlns:r="http://schemas.openxmlformats.org/officeDocument/2006/relationships">
+<p:sld xmlns:a="http://schemas.openxmlformats.org/drawingml/2006/main" xmlns:r="http://schemas.openxmlformats.org/officeDocument/2006/relationships" xmlns:p="http://schemas.openxmlformats.org/presentationml/2006/main">
   <p:cSld>
     <p:spTree>
       <p:nvGrpSpPr>
@@ -3471,7 +3477,14 @@
         <p:cNvGrpSpPr/>
         <p:nvPr/>
       </p:nvGrpSpPr>
-      <p:grpSpPr/>
+      <p:grpSpPr>
+        <a:xfrm>
+          <a:off x="0" y="0"/>
+          <a:ext cx="0" cy="0"/>
+          <a:chOff x="0" y="0"/>
+          <a:chExt cx="0" cy="0"/>
+        </a:xfrm>
+      </p:grpSpPr>
       <p:sp>
         <p:nvSpPr>
           <p:cNvPr id="2" name="Rectangle 1"/>
@@ -3513,6 +3526,7 @@
           <a:lstStyle/>
           <a:p>
             <a:pPr algn="ctr"/>
+            <a:endParaRPr/>
           </a:p>
         </p:txBody>
       </p:sp>
@@ -3557,6 +3571,7 @@
           <a:lstStyle/>
           <a:p>
             <a:pPr algn="ctr"/>
+            <a:endParaRPr/>
           </a:p>
         </p:txBody>
       </p:sp>
@@ -3636,6 +3651,7 @@
           <a:lstStyle/>
           <a:p>
             <a:pPr algn="ctr"/>
+            <a:endParaRPr/>
           </a:p>
         </p:txBody>
       </p:sp>
@@ -3939,7 +3955,7 @@
 </file>
 
 <file path=ppt/slides/slide11.xml><?xml version="1.0" encoding="utf-8"?>
-<p:sld xmlns:a="http://schemas.openxmlformats.org/drawingml/2006/main" xmlns:p="http://schemas.openxmlformats.org/presentationml/2006/main" xmlns:r="http://schemas.openxmlformats.org/officeDocument/2006/relationships">
+<p:sld xmlns:a="http://schemas.openxmlformats.org/drawingml/2006/main" xmlns:r="http://schemas.openxmlformats.org/officeDocument/2006/relationships" xmlns:p="http://schemas.openxmlformats.org/presentationml/2006/main">
   <p:cSld>
     <p:spTree>
       <p:nvGrpSpPr>
@@ -3947,7 +3963,14 @@
         <p:cNvGrpSpPr/>
         <p:nvPr/>
       </p:nvGrpSpPr>
-      <p:grpSpPr/>
+      <p:grpSpPr>
+        <a:xfrm>
+          <a:off x="0" y="0"/>
+          <a:ext cx="0" cy="0"/>
+          <a:chOff x="0" y="0"/>
+          <a:chExt cx="0" cy="0"/>
+        </a:xfrm>
+      </p:grpSpPr>
       <p:sp>
         <p:nvSpPr>
           <p:cNvPr id="2" name="Rectangle 1"/>
@@ -3989,6 +4012,7 @@
           <a:lstStyle/>
           <a:p>
             <a:pPr algn="ctr"/>
+            <a:endParaRPr/>
           </a:p>
         </p:txBody>
       </p:sp>
@@ -4033,6 +4057,7 @@
           <a:lstStyle/>
           <a:p>
             <a:pPr algn="ctr"/>
+            <a:endParaRPr/>
           </a:p>
         </p:txBody>
       </p:sp>
@@ -4112,6 +4137,7 @@
           <a:lstStyle/>
           <a:p>
             <a:pPr algn="ctr"/>
+            <a:endParaRPr/>
           </a:p>
         </p:txBody>
       </p:sp>
@@ -4415,7 +4441,7 @@
 </file>
 
 <file path=ppt/slides/slide12.xml><?xml version="1.0" encoding="utf-8"?>
-<p:sld xmlns:a="http://schemas.openxmlformats.org/drawingml/2006/main" xmlns:p="http://schemas.openxmlformats.org/presentationml/2006/main" xmlns:r="http://schemas.openxmlformats.org/officeDocument/2006/relationships">
+<p:sld xmlns:a="http://schemas.openxmlformats.org/drawingml/2006/main" xmlns:r="http://schemas.openxmlformats.org/officeDocument/2006/relationships" xmlns:p="http://schemas.openxmlformats.org/presentationml/2006/main">
   <p:cSld>
     <p:spTree>
       <p:nvGrpSpPr>
@@ -4423,7 +4449,14 @@
         <p:cNvGrpSpPr/>
         <p:nvPr/>
       </p:nvGrpSpPr>
-      <p:grpSpPr/>
+      <p:grpSpPr>
+        <a:xfrm>
+          <a:off x="0" y="0"/>
+          <a:ext cx="0" cy="0"/>
+          <a:chOff x="0" y="0"/>
+          <a:chExt cx="0" cy="0"/>
+        </a:xfrm>
+      </p:grpSpPr>
       <p:sp>
         <p:nvSpPr>
           <p:cNvPr id="2" name="Rectangle 1"/>
@@ -4465,6 +4498,7 @@
           <a:lstStyle/>
           <a:p>
             <a:pPr algn="ctr"/>
+            <a:endParaRPr/>
           </a:p>
         </p:txBody>
       </p:sp>
@@ -4509,6 +4543,7 @@
           <a:lstStyle/>
           <a:p>
             <a:pPr algn="ctr"/>
+            <a:endParaRPr/>
           </a:p>
         </p:txBody>
       </p:sp>
@@ -4588,6 +4623,7 @@
           <a:lstStyle/>
           <a:p>
             <a:pPr algn="ctr"/>
+            <a:endParaRPr/>
           </a:p>
         </p:txBody>
       </p:sp>
@@ -5070,7 +5106,7 @@
 </file>
 
 <file path=ppt/slides/slide13.xml><?xml version="1.0" encoding="utf-8"?>
-<p:sld xmlns:a="http://schemas.openxmlformats.org/drawingml/2006/main" xmlns:p="http://schemas.openxmlformats.org/presentationml/2006/main" xmlns:r="http://schemas.openxmlformats.org/officeDocument/2006/relationships">
+<p:sld xmlns:a="http://schemas.openxmlformats.org/drawingml/2006/main" xmlns:r="http://schemas.openxmlformats.org/officeDocument/2006/relationships" xmlns:p="http://schemas.openxmlformats.org/presentationml/2006/main">
   <p:cSld>
     <p:spTree>
       <p:nvGrpSpPr>
@@ -5078,7 +5114,14 @@
         <p:cNvGrpSpPr/>
         <p:nvPr/>
       </p:nvGrpSpPr>
-      <p:grpSpPr/>
+      <p:grpSpPr>
+        <a:xfrm>
+          <a:off x="0" y="0"/>
+          <a:ext cx="0" cy="0"/>
+          <a:chOff x="0" y="0"/>
+          <a:chExt cx="0" cy="0"/>
+        </a:xfrm>
+      </p:grpSpPr>
       <p:sp>
         <p:nvSpPr>
           <p:cNvPr id="2" name="Rectangle 1"/>
@@ -5120,6 +5163,7 @@
           <a:lstStyle/>
           <a:p>
             <a:pPr algn="ctr"/>
+            <a:endParaRPr/>
           </a:p>
         </p:txBody>
       </p:sp>
@@ -5164,6 +5208,7 @@
           <a:lstStyle/>
           <a:p>
             <a:pPr algn="ctr"/>
+            <a:endParaRPr/>
           </a:p>
         </p:txBody>
       </p:sp>
@@ -5243,6 +5288,7 @@
           <a:lstStyle/>
           <a:p>
             <a:pPr algn="ctr"/>
+            <a:endParaRPr/>
           </a:p>
         </p:txBody>
       </p:sp>
@@ -5818,7 +5864,7 @@
 </file>
 
 <file path=ppt/slides/slide14.xml><?xml version="1.0" encoding="utf-8"?>
-<p:sld xmlns:a="http://schemas.openxmlformats.org/drawingml/2006/main" xmlns:p="http://schemas.openxmlformats.org/presentationml/2006/main" xmlns:r="http://schemas.openxmlformats.org/officeDocument/2006/relationships">
+<p:sld xmlns:a="http://schemas.openxmlformats.org/drawingml/2006/main" xmlns:r="http://schemas.openxmlformats.org/officeDocument/2006/relationships" xmlns:p="http://schemas.openxmlformats.org/presentationml/2006/main">
   <p:cSld>
     <p:spTree>
       <p:nvGrpSpPr>
@@ -5826,7 +5872,14 @@
         <p:cNvGrpSpPr/>
         <p:nvPr/>
       </p:nvGrpSpPr>
-      <p:grpSpPr/>
+      <p:grpSpPr>
+        <a:xfrm>
+          <a:off x="0" y="0"/>
+          <a:ext cx="0" cy="0"/>
+          <a:chOff x="0" y="0"/>
+          <a:chExt cx="0" cy="0"/>
+        </a:xfrm>
+      </p:grpSpPr>
       <p:sp>
         <p:nvSpPr>
           <p:cNvPr id="2" name="Rectangle 1"/>
@@ -5868,6 +5921,7 @@
           <a:lstStyle/>
           <a:p>
             <a:pPr algn="ctr"/>
+            <a:endParaRPr/>
           </a:p>
         </p:txBody>
       </p:sp>
@@ -5912,6 +5966,7 @@
           <a:lstStyle/>
           <a:p>
             <a:pPr algn="ctr"/>
+            <a:endParaRPr/>
           </a:p>
         </p:txBody>
       </p:sp>
@@ -5991,6 +6046,7 @@
           <a:lstStyle/>
           <a:p>
             <a:pPr algn="ctr"/>
+            <a:endParaRPr/>
           </a:p>
         </p:txBody>
       </p:sp>
@@ -6224,7 +6280,7 @@
 </file>
 
 <file path=ppt/slides/slide15.xml><?xml version="1.0" encoding="utf-8"?>
-<p:sld xmlns:a="http://schemas.openxmlformats.org/drawingml/2006/main" xmlns:p="http://schemas.openxmlformats.org/presentationml/2006/main" xmlns:r="http://schemas.openxmlformats.org/officeDocument/2006/relationships">
+<p:sld xmlns:a="http://schemas.openxmlformats.org/drawingml/2006/main" xmlns:r="http://schemas.openxmlformats.org/officeDocument/2006/relationships" xmlns:p="http://schemas.openxmlformats.org/presentationml/2006/main">
   <p:cSld>
     <p:spTree>
       <p:nvGrpSpPr>
@@ -6232,7 +6288,14 @@
         <p:cNvGrpSpPr/>
         <p:nvPr/>
       </p:nvGrpSpPr>
-      <p:grpSpPr/>
+      <p:grpSpPr>
+        <a:xfrm>
+          <a:off x="0" y="0"/>
+          <a:ext cx="0" cy="0"/>
+          <a:chOff x="0" y="0"/>
+          <a:chExt cx="0" cy="0"/>
+        </a:xfrm>
+      </p:grpSpPr>
       <p:sp>
         <p:nvSpPr>
           <p:cNvPr id="2" name="Rectangle 1"/>
@@ -6274,6 +6337,7 @@
           <a:lstStyle/>
           <a:p>
             <a:pPr algn="ctr"/>
+            <a:endParaRPr/>
           </a:p>
         </p:txBody>
       </p:sp>
@@ -6318,6 +6382,7 @@
           <a:lstStyle/>
           <a:p>
             <a:pPr algn="ctr"/>
+            <a:endParaRPr/>
           </a:p>
         </p:txBody>
       </p:sp>
@@ -6397,6 +6462,7 @@
           <a:lstStyle/>
           <a:p>
             <a:pPr algn="ctr"/>
+            <a:endParaRPr/>
           </a:p>
         </p:txBody>
       </p:sp>
@@ -6476,6 +6542,7 @@
           <a:lstStyle/>
           <a:p>
             <a:pPr algn="ctr"/>
+            <a:endParaRPr/>
           </a:p>
         </p:txBody>
       </p:sp>
@@ -6488,7 +6555,7 @@
 </file>
 
 <file path=ppt/slides/slide2.xml><?xml version="1.0" encoding="utf-8"?>
-<p:sld xmlns:a="http://schemas.openxmlformats.org/drawingml/2006/main" xmlns:p="http://schemas.openxmlformats.org/presentationml/2006/main" xmlns:r="http://schemas.openxmlformats.org/officeDocument/2006/relationships">
+<p:sld xmlns:a="http://schemas.openxmlformats.org/drawingml/2006/main" xmlns:r="http://schemas.openxmlformats.org/officeDocument/2006/relationships" xmlns:p="http://schemas.openxmlformats.org/presentationml/2006/main">
   <p:cSld>
     <p:spTree>
       <p:nvGrpSpPr>
@@ -6496,7 +6563,14 @@
         <p:cNvGrpSpPr/>
         <p:nvPr/>
       </p:nvGrpSpPr>
-      <p:grpSpPr/>
+      <p:grpSpPr>
+        <a:xfrm>
+          <a:off x="0" y="0"/>
+          <a:ext cx="0" cy="0"/>
+          <a:chOff x="0" y="0"/>
+          <a:chExt cx="0" cy="0"/>
+        </a:xfrm>
+      </p:grpSpPr>
       <p:sp>
         <p:nvSpPr>
           <p:cNvPr id="2" name="Rectangle 1"/>
@@ -6538,6 +6612,7 @@
           <a:lstStyle/>
           <a:p>
             <a:pPr algn="ctr"/>
+            <a:endParaRPr/>
           </a:p>
         </p:txBody>
       </p:sp>
@@ -6582,6 +6657,7 @@
           <a:lstStyle/>
           <a:p>
             <a:pPr algn="ctr"/>
+            <a:endParaRPr/>
           </a:p>
         </p:txBody>
       </p:sp>
@@ -6661,6 +6737,7 @@
           <a:lstStyle/>
           <a:p>
             <a:pPr algn="ctr"/>
+            <a:endParaRPr/>
           </a:p>
         </p:txBody>
       </p:sp>
@@ -6810,6 +6887,7 @@
           <a:lstStyle/>
           <a:p>
             <a:pPr algn="ctr"/>
+            <a:endParaRPr/>
           </a:p>
         </p:txBody>
       </p:sp>
@@ -6924,6 +7002,7 @@
           <a:lstStyle/>
           <a:p>
             <a:pPr algn="ctr"/>
+            <a:endParaRPr/>
           </a:p>
         </p:txBody>
       </p:sp>
@@ -6971,7 +7050,7 @@
         <p:spPr>
           <a:xfrm>
             <a:off x="1200000" y="5500000"/>
-            <a:ext cx="10000000" cy="1100000"/>
+            <a:ext cx="10000000" cy="1261884"/>
           </a:xfrm>
           <a:prstGeom prst="rect">
             <a:avLst/>
@@ -7018,6 +7097,21 @@
               </a:rPr>
               <a:t>Nguyễn Quang Huy — 22810310051</a:t>
             </a:r>
+            <a:endParaRPr lang="en-US" sz="1900" b="0" i="0">
+              <a:solidFill>
+                <a:srgbClr val="C9D8E4"/>
+              </a:solidFill>
+              <a:latin typeface="Arial"/>
+            </a:endParaRPr>
+          </a:p>
+          <a:p>
+            <a:pPr algn="l"/>
+            <a:endParaRPr sz="1900" b="0" i="0">
+              <a:solidFill>
+                <a:srgbClr val="C9D8E4"/>
+              </a:solidFill>
+              <a:latin typeface="Arial"/>
+            </a:endParaRPr>
           </a:p>
         </p:txBody>
       </p:sp>
@@ -7030,7 +7124,7 @@
 </file>
 
 <file path=ppt/slides/slide3.xml><?xml version="1.0" encoding="utf-8"?>
-<p:sld xmlns:a="http://schemas.openxmlformats.org/drawingml/2006/main" xmlns:p="http://schemas.openxmlformats.org/presentationml/2006/main" xmlns:r="http://schemas.openxmlformats.org/officeDocument/2006/relationships">
+<p:sld xmlns:a="http://schemas.openxmlformats.org/drawingml/2006/main" xmlns:r="http://schemas.openxmlformats.org/officeDocument/2006/relationships" xmlns:p="http://schemas.openxmlformats.org/presentationml/2006/main">
   <p:cSld>
     <p:spTree>
       <p:nvGrpSpPr>
@@ -7038,7 +7132,14 @@
         <p:cNvGrpSpPr/>
         <p:nvPr/>
       </p:nvGrpSpPr>
-      <p:grpSpPr/>
+      <p:grpSpPr>
+        <a:xfrm>
+          <a:off x="0" y="0"/>
+          <a:ext cx="0" cy="0"/>
+          <a:chOff x="0" y="0"/>
+          <a:chExt cx="0" cy="0"/>
+        </a:xfrm>
+      </p:grpSpPr>
       <p:sp>
         <p:nvSpPr>
           <p:cNvPr id="2" name="Rectangle 1"/>
@@ -7080,6 +7181,7 @@
           <a:lstStyle/>
           <a:p>
             <a:pPr algn="ctr"/>
+            <a:endParaRPr/>
           </a:p>
         </p:txBody>
       </p:sp>
@@ -7124,6 +7226,7 @@
           <a:lstStyle/>
           <a:p>
             <a:pPr algn="ctr"/>
+            <a:endParaRPr/>
           </a:p>
         </p:txBody>
       </p:sp>
@@ -7203,6 +7306,7 @@
           <a:lstStyle/>
           <a:p>
             <a:pPr algn="ctr"/>
+            <a:endParaRPr/>
           </a:p>
         </p:txBody>
       </p:sp>
@@ -7652,7 +7756,7 @@
 </file>
 
 <file path=ppt/slides/slide4.xml><?xml version="1.0" encoding="utf-8"?>
-<p:sld xmlns:a="http://schemas.openxmlformats.org/drawingml/2006/main" xmlns:p="http://schemas.openxmlformats.org/presentationml/2006/main" xmlns:r="http://schemas.openxmlformats.org/officeDocument/2006/relationships">
+<p:sld xmlns:a="http://schemas.openxmlformats.org/drawingml/2006/main" xmlns:r="http://schemas.openxmlformats.org/officeDocument/2006/relationships" xmlns:p="http://schemas.openxmlformats.org/presentationml/2006/main">
   <p:cSld>
     <p:spTree>
       <p:nvGrpSpPr>
@@ -7660,7 +7764,14 @@
         <p:cNvGrpSpPr/>
         <p:nvPr/>
       </p:nvGrpSpPr>
-      <p:grpSpPr/>
+      <p:grpSpPr>
+        <a:xfrm>
+          <a:off x="0" y="0"/>
+          <a:ext cx="0" cy="0"/>
+          <a:chOff x="0" y="0"/>
+          <a:chExt cx="0" cy="0"/>
+        </a:xfrm>
+      </p:grpSpPr>
       <p:sp>
         <p:nvSpPr>
           <p:cNvPr id="2" name="Rectangle 1"/>
@@ -7702,6 +7813,7 @@
           <a:lstStyle/>
           <a:p>
             <a:pPr algn="ctr"/>
+            <a:endParaRPr/>
           </a:p>
         </p:txBody>
       </p:sp>
@@ -7746,6 +7858,7 @@
           <a:lstStyle/>
           <a:p>
             <a:pPr algn="ctr"/>
+            <a:endParaRPr/>
           </a:p>
         </p:txBody>
       </p:sp>
@@ -7825,6 +7938,7 @@
           <a:lstStyle/>
           <a:p>
             <a:pPr algn="ctr"/>
+            <a:endParaRPr/>
           </a:p>
         </p:txBody>
       </p:sp>
@@ -8035,7 +8149,7 @@
 </file>
 
 <file path=ppt/slides/slide5.xml><?xml version="1.0" encoding="utf-8"?>
-<p:sld xmlns:a="http://schemas.openxmlformats.org/drawingml/2006/main" xmlns:p="http://schemas.openxmlformats.org/presentationml/2006/main" xmlns:r="http://schemas.openxmlformats.org/officeDocument/2006/relationships">
+<p:sld xmlns:a="http://schemas.openxmlformats.org/drawingml/2006/main" xmlns:r="http://schemas.openxmlformats.org/officeDocument/2006/relationships" xmlns:p="http://schemas.openxmlformats.org/presentationml/2006/main">
   <p:cSld>
     <p:spTree>
       <p:nvGrpSpPr>
@@ -8043,7 +8157,14 @@
         <p:cNvGrpSpPr/>
         <p:nvPr/>
       </p:nvGrpSpPr>
-      <p:grpSpPr/>
+      <p:grpSpPr>
+        <a:xfrm>
+          <a:off x="0" y="0"/>
+          <a:ext cx="0" cy="0"/>
+          <a:chOff x="0" y="0"/>
+          <a:chExt cx="0" cy="0"/>
+        </a:xfrm>
+      </p:grpSpPr>
       <p:sp>
         <p:nvSpPr>
           <p:cNvPr id="2" name="Rectangle 1"/>
@@ -8085,6 +8206,7 @@
           <a:lstStyle/>
           <a:p>
             <a:pPr algn="ctr"/>
+            <a:endParaRPr/>
           </a:p>
         </p:txBody>
       </p:sp>
@@ -8129,6 +8251,7 @@
           <a:lstStyle/>
           <a:p>
             <a:pPr algn="ctr"/>
+            <a:endParaRPr/>
           </a:p>
         </p:txBody>
       </p:sp>
@@ -8208,6 +8331,7 @@
           <a:lstStyle/>
           <a:p>
             <a:pPr algn="ctr"/>
+            <a:endParaRPr/>
           </a:p>
         </p:txBody>
       </p:sp>
@@ -8418,7 +8542,7 @@
 </file>
 
 <file path=ppt/slides/slide6.xml><?xml version="1.0" encoding="utf-8"?>
-<p:sld xmlns:a="http://schemas.openxmlformats.org/drawingml/2006/main" xmlns:p="http://schemas.openxmlformats.org/presentationml/2006/main" xmlns:r="http://schemas.openxmlformats.org/officeDocument/2006/relationships">
+<p:sld xmlns:a="http://schemas.openxmlformats.org/drawingml/2006/main" xmlns:r="http://schemas.openxmlformats.org/officeDocument/2006/relationships" xmlns:p="http://schemas.openxmlformats.org/presentationml/2006/main">
   <p:cSld>
     <p:spTree>
       <p:nvGrpSpPr>
@@ -8426,7 +8550,14 @@
         <p:cNvGrpSpPr/>
         <p:nvPr/>
       </p:nvGrpSpPr>
-      <p:grpSpPr/>
+      <p:grpSpPr>
+        <a:xfrm>
+          <a:off x="0" y="0"/>
+          <a:ext cx="0" cy="0"/>
+          <a:chOff x="0" y="0"/>
+          <a:chExt cx="0" cy="0"/>
+        </a:xfrm>
+      </p:grpSpPr>
       <p:sp>
         <p:nvSpPr>
           <p:cNvPr id="2" name="Rectangle 1"/>
@@ -8468,6 +8599,7 @@
           <a:lstStyle/>
           <a:p>
             <a:pPr algn="ctr"/>
+            <a:endParaRPr/>
           </a:p>
         </p:txBody>
       </p:sp>
@@ -8512,6 +8644,7 @@
           <a:lstStyle/>
           <a:p>
             <a:pPr algn="ctr"/>
+            <a:endParaRPr/>
           </a:p>
         </p:txBody>
       </p:sp>
@@ -8591,6 +8724,7 @@
           <a:lstStyle/>
           <a:p>
             <a:pPr algn="ctr"/>
+            <a:endParaRPr/>
           </a:p>
         </p:txBody>
       </p:sp>
@@ -8801,7 +8935,7 @@
 </file>
 
 <file path=ppt/slides/slide7.xml><?xml version="1.0" encoding="utf-8"?>
-<p:sld xmlns:a="http://schemas.openxmlformats.org/drawingml/2006/main" xmlns:p="http://schemas.openxmlformats.org/presentationml/2006/main" xmlns:r="http://schemas.openxmlformats.org/officeDocument/2006/relationships">
+<p:sld xmlns:a="http://schemas.openxmlformats.org/drawingml/2006/main" xmlns:r="http://schemas.openxmlformats.org/officeDocument/2006/relationships" xmlns:p="http://schemas.openxmlformats.org/presentationml/2006/main">
   <p:cSld>
     <p:spTree>
       <p:nvGrpSpPr>
@@ -8809,7 +8943,14 @@
         <p:cNvGrpSpPr/>
         <p:nvPr/>
       </p:nvGrpSpPr>
-      <p:grpSpPr/>
+      <p:grpSpPr>
+        <a:xfrm>
+          <a:off x="0" y="0"/>
+          <a:ext cx="0" cy="0"/>
+          <a:chOff x="0" y="0"/>
+          <a:chExt cx="0" cy="0"/>
+        </a:xfrm>
+      </p:grpSpPr>
       <p:sp>
         <p:nvSpPr>
           <p:cNvPr id="2" name="Rectangle 1"/>
@@ -8851,6 +8992,7 @@
           <a:lstStyle/>
           <a:p>
             <a:pPr algn="ctr"/>
+            <a:endParaRPr/>
           </a:p>
         </p:txBody>
       </p:sp>
@@ -8895,6 +9037,7 @@
           <a:lstStyle/>
           <a:p>
             <a:pPr algn="ctr"/>
+            <a:endParaRPr/>
           </a:p>
         </p:txBody>
       </p:sp>
@@ -8974,6 +9117,7 @@
           <a:lstStyle/>
           <a:p>
             <a:pPr algn="ctr"/>
+            <a:endParaRPr/>
           </a:p>
         </p:txBody>
       </p:sp>
@@ -9121,6 +9265,7 @@
           <a:lstStyle/>
           <a:p>
             <a:pPr algn="ctr"/>
+            <a:endParaRPr/>
           </a:p>
         </p:txBody>
       </p:sp>
@@ -9233,6 +9378,7 @@
           <a:lstStyle/>
           <a:p>
             <a:pPr algn="ctr"/>
+            <a:endParaRPr/>
           </a:p>
         </p:txBody>
       </p:sp>
@@ -9475,7 +9621,7 @@
 </file>
 
 <file path=ppt/slides/slide8.xml><?xml version="1.0" encoding="utf-8"?>
-<p:sld xmlns:a="http://schemas.openxmlformats.org/drawingml/2006/main" xmlns:p="http://schemas.openxmlformats.org/presentationml/2006/main" xmlns:r="http://schemas.openxmlformats.org/officeDocument/2006/relationships">
+<p:sld xmlns:a="http://schemas.openxmlformats.org/drawingml/2006/main" xmlns:r="http://schemas.openxmlformats.org/officeDocument/2006/relationships" xmlns:p="http://schemas.openxmlformats.org/presentationml/2006/main">
   <p:cSld>
     <p:spTree>
       <p:nvGrpSpPr>
@@ -9483,7 +9629,14 @@
         <p:cNvGrpSpPr/>
         <p:nvPr/>
       </p:nvGrpSpPr>
-      <p:grpSpPr/>
+      <p:grpSpPr>
+        <a:xfrm>
+          <a:off x="0" y="0"/>
+          <a:ext cx="0" cy="0"/>
+          <a:chOff x="0" y="0"/>
+          <a:chExt cx="0" cy="0"/>
+        </a:xfrm>
+      </p:grpSpPr>
       <p:sp>
         <p:nvSpPr>
           <p:cNvPr id="2" name="Rectangle 1"/>
@@ -9525,6 +9678,7 @@
           <a:lstStyle/>
           <a:p>
             <a:pPr algn="ctr"/>
+            <a:endParaRPr/>
           </a:p>
         </p:txBody>
       </p:sp>
@@ -9569,6 +9723,7 @@
           <a:lstStyle/>
           <a:p>
             <a:pPr algn="ctr"/>
+            <a:endParaRPr/>
           </a:p>
         </p:txBody>
       </p:sp>
@@ -9648,6 +9803,7 @@
           <a:lstStyle/>
           <a:p>
             <a:pPr algn="ctr"/>
+            <a:endParaRPr/>
           </a:p>
         </p:txBody>
       </p:sp>
@@ -10091,7 +10247,7 @@
 </file>
 
 <file path=ppt/slides/slide9.xml><?xml version="1.0" encoding="utf-8"?>
-<p:sld xmlns:a="http://schemas.openxmlformats.org/drawingml/2006/main" xmlns:p="http://schemas.openxmlformats.org/presentationml/2006/main" xmlns:r="http://schemas.openxmlformats.org/officeDocument/2006/relationships">
+<p:sld xmlns:a="http://schemas.openxmlformats.org/drawingml/2006/main" xmlns:r="http://schemas.openxmlformats.org/officeDocument/2006/relationships" xmlns:p="http://schemas.openxmlformats.org/presentationml/2006/main">
   <p:cSld>
     <p:spTree>
       <p:nvGrpSpPr>
@@ -10099,7 +10255,14 @@
         <p:cNvGrpSpPr/>
         <p:nvPr/>
       </p:nvGrpSpPr>
-      <p:grpSpPr/>
+      <p:grpSpPr>
+        <a:xfrm>
+          <a:off x="0" y="0"/>
+          <a:ext cx="0" cy="0"/>
+          <a:chOff x="0" y="0"/>
+          <a:chExt cx="0" cy="0"/>
+        </a:xfrm>
+      </p:grpSpPr>
       <p:sp>
         <p:nvSpPr>
           <p:cNvPr id="2" name="Rectangle 1"/>
@@ -10141,6 +10304,7 @@
           <a:lstStyle/>
           <a:p>
             <a:pPr algn="ctr"/>
+            <a:endParaRPr/>
           </a:p>
         </p:txBody>
       </p:sp>
@@ -10185,6 +10349,7 @@
           <a:lstStyle/>
           <a:p>
             <a:pPr algn="ctr"/>
+            <a:endParaRPr/>
           </a:p>
         </p:txBody>
       </p:sp>
@@ -10264,6 +10429,7 @@
           <a:lstStyle/>
           <a:p>
             <a:pPr algn="ctr"/>
+            <a:endParaRPr/>
           </a:p>
         </p:txBody>
       </p:sp>
@@ -10400,6 +10566,7 @@
           <a:lstStyle/>
           <a:p>
             <a:pPr algn="ctr"/>
+            <a:endParaRPr/>
           </a:p>
         </p:txBody>
       </p:sp>
@@ -10500,6 +10667,7 @@
           <a:lstStyle/>
           <a:p>
             <a:pPr algn="ctr"/>
+            <a:endParaRPr/>
           </a:p>
         </p:txBody>
       </p:sp>
@@ -10600,6 +10768,7 @@
           <a:lstStyle/>
           <a:p>
             <a:pPr algn="ctr"/>
+            <a:endParaRPr/>
           </a:p>
         </p:txBody>
       </p:sp>
@@ -10700,6 +10869,7 @@
           <a:lstStyle/>
           <a:p>
             <a:pPr algn="ctr"/>
+            <a:endParaRPr/>
           </a:p>
         </p:txBody>
       </p:sp>
@@ -10800,6 +10970,7 @@
           <a:lstStyle/>
           <a:p>
             <a:pPr algn="ctr"/>
+            <a:endParaRPr/>
           </a:p>
         </p:txBody>
       </p:sp>
@@ -10900,6 +11071,7 @@
           <a:lstStyle/>
           <a:p>
             <a:pPr algn="ctr"/>
+            <a:endParaRPr/>
           </a:p>
         </p:txBody>
       </p:sp>

</xml_diff>

<commit_message>
docs: cap nhat bao cao va slide theo tinh nang moi nhat
- Bao cao: them co che tu duyet cham 24h khi het neo tin cay (giu kin
  khoi UI), nhan dien thiet bi theo phien ban trinh duyet + IP + UA,
  notification tach theo chu the (vi tu quan thiet bi, admin chi nhan
  vi moi), badge dem ca session pending, schema DeviceSession bo sung
  ip/userAgent/otpFailed, 2 dong moi trong ma tran moi de doa
- Slide: bo sung nhan dien thiet bi + co che cho 24h
</commit_message>
<xml_diff>
--- a/LeHongLinh_Slides.pptx
+++ b/LeHongLinh_Slides.pptx
@@ -5,23 +5,23 @@
     <p:sldMasterId id="2147483648" r:id="rId1"/>
   </p:sldMasterIdLst>
   <p:sldIdLst>
-    <p:sldId id="256" r:id="rId2"/>
-    <p:sldId id="257" r:id="rId3"/>
-    <p:sldId id="258" r:id="rId4"/>
-    <p:sldId id="259" r:id="rId5"/>
-    <p:sldId id="260" r:id="rId6"/>
-    <p:sldId id="261" r:id="rId7"/>
-    <p:sldId id="262" r:id="rId8"/>
-    <p:sldId id="263" r:id="rId9"/>
-    <p:sldId id="264" r:id="rId10"/>
-    <p:sldId id="265" r:id="rId11"/>
-    <p:sldId id="266" r:id="rId12"/>
-    <p:sldId id="267" r:id="rId13"/>
-    <p:sldId id="268" r:id="rId14"/>
-    <p:sldId id="269" r:id="rId15"/>
-    <p:sldId id="270" r:id="rId16"/>
+    <p:sldId id="256" r:id="rId7"/>
+    <p:sldId id="257" r:id="rId8"/>
+    <p:sldId id="258" r:id="rId9"/>
+    <p:sldId id="259" r:id="rId10"/>
+    <p:sldId id="260" r:id="rId11"/>
+    <p:sldId id="261" r:id="rId12"/>
+    <p:sldId id="262" r:id="rId13"/>
+    <p:sldId id="263" r:id="rId14"/>
+    <p:sldId id="264" r:id="rId15"/>
+    <p:sldId id="265" r:id="rId16"/>
+    <p:sldId id="266" r:id="rId17"/>
+    <p:sldId id="267" r:id="rId18"/>
+    <p:sldId id="268" r:id="rId19"/>
+    <p:sldId id="269" r:id="rId20"/>
+    <p:sldId id="270" r:id="rId21"/>
   </p:sldIdLst>
-  <p:sldSz cx="12192000" cy="6858000"/>
+  <p:sldSz cx="12192000" cy="6858000" type="screen4x3"/>
   <p:notesSz cx="6858000" cy="9144000"/>
   <p:defaultTextStyle>
     <a:defPPr>
@@ -118,22 +118,6 @@
       </a:defRPr>
     </a:lvl9pPr>
   </p:defaultTextStyle>
-  <p:extLst>
-    <p:ext uri="{EFAFB233-063F-42B5-8137-9DF3F51BA10A}">
-      <p15:sldGuideLst xmlns:p15="http://schemas.microsoft.com/office/powerpoint/2012/main">
-        <p15:guide id="1" orient="horz" pos="2160">
-          <p15:clr>
-            <a:srgbClr val="A4A3A4"/>
-          </p15:clr>
-        </p15:guide>
-        <p15:guide id="2" pos="2880">
-          <p15:clr>
-            <a:srgbClr val="A4A3A4"/>
-          </p15:clr>
-        </p15:guide>
-      </p15:sldGuideLst>
-    </p:ext>
-  </p:extLst>
 </p:presentation>
 </file>
 
@@ -175,9 +159,10 @@
           <a:lstStyle/>
           <a:p>
             <a:r>
-              <a:rPr lang="en-US"/>
+              <a:rPr lang="en-US" smtClean="0"/>
               <a:t>Click to edit Master title style</a:t>
             </a:r>
+            <a:endParaRPr lang="en-US"/>
           </a:p>
         </p:txBody>
       </p:sp>
@@ -293,9 +278,10 @@
           </a:lstStyle>
           <a:p>
             <a:r>
-              <a:rPr lang="en-US"/>
+              <a:rPr lang="en-US" smtClean="0"/>
               <a:t>Click to edit Master subtitle style</a:t>
             </a:r>
+            <a:endParaRPr lang="en-US"/>
           </a:p>
         </p:txBody>
       </p:sp>
@@ -316,7 +302,7 @@
           <a:p>
             <a:fld id="{5BCAD085-E8A6-8845-BD4E-CB4CCA059FC4}" type="datetimeFigureOut">
               <a:rPr lang="en-US" smtClean="0"/>
-              <a:t>10/12/2026</a:t>
+              <a:t>1/27/13</a:t>
             </a:fld>
             <a:endParaRPr lang="en-US"/>
           </a:p>
@@ -410,9 +396,10 @@
           <a:lstStyle/>
           <a:p>
             <a:r>
-              <a:rPr lang="en-US"/>
+              <a:rPr lang="en-US" smtClean="0"/>
               <a:t>Click to edit Master title style</a:t>
             </a:r>
+            <a:endParaRPr lang="en-US"/>
           </a:p>
         </p:txBody>
       </p:sp>
@@ -433,37 +420,38 @@
           <a:p>
             <a:pPr lvl="0"/>
             <a:r>
-              <a:rPr lang="en-US"/>
+              <a:rPr lang="en-US" smtClean="0"/>
               <a:t>Click to edit Master text styles</a:t>
             </a:r>
           </a:p>
           <a:p>
             <a:pPr lvl="1"/>
             <a:r>
-              <a:rPr lang="en-US"/>
+              <a:rPr lang="en-US" smtClean="0"/>
               <a:t>Second level</a:t>
             </a:r>
           </a:p>
           <a:p>
             <a:pPr lvl="2"/>
             <a:r>
-              <a:rPr lang="en-US"/>
+              <a:rPr lang="en-US" smtClean="0"/>
               <a:t>Third level</a:t>
             </a:r>
           </a:p>
           <a:p>
             <a:pPr lvl="3"/>
             <a:r>
-              <a:rPr lang="en-US"/>
+              <a:rPr lang="en-US" smtClean="0"/>
               <a:t>Fourth level</a:t>
             </a:r>
           </a:p>
           <a:p>
             <a:pPr lvl="4"/>
             <a:r>
-              <a:rPr lang="en-US"/>
+              <a:rPr lang="en-US" smtClean="0"/>
               <a:t>Fifth level</a:t>
             </a:r>
+            <a:endParaRPr lang="en-US"/>
           </a:p>
         </p:txBody>
       </p:sp>
@@ -484,7 +472,7 @@
           <a:p>
             <a:fld id="{5BCAD085-E8A6-8845-BD4E-CB4CCA059FC4}" type="datetimeFigureOut">
               <a:rPr lang="en-US" smtClean="0"/>
-              <a:t>10/12/2026</a:t>
+              <a:t>1/27/13</a:t>
             </a:fld>
             <a:endParaRPr lang="en-US"/>
           </a:p>
@@ -583,9 +571,10 @@
           <a:lstStyle/>
           <a:p>
             <a:r>
-              <a:rPr lang="en-US"/>
+              <a:rPr lang="en-US" smtClean="0"/>
               <a:t>Click to edit Master title style</a:t>
             </a:r>
+            <a:endParaRPr lang="en-US"/>
           </a:p>
         </p:txBody>
       </p:sp>
@@ -611,37 +600,38 @@
           <a:p>
             <a:pPr lvl="0"/>
             <a:r>
-              <a:rPr lang="en-US"/>
+              <a:rPr lang="en-US" smtClean="0"/>
               <a:t>Click to edit Master text styles</a:t>
             </a:r>
           </a:p>
           <a:p>
             <a:pPr lvl="1"/>
             <a:r>
-              <a:rPr lang="en-US"/>
+              <a:rPr lang="en-US" smtClean="0"/>
               <a:t>Second level</a:t>
             </a:r>
           </a:p>
           <a:p>
             <a:pPr lvl="2"/>
             <a:r>
-              <a:rPr lang="en-US"/>
+              <a:rPr lang="en-US" smtClean="0"/>
               <a:t>Third level</a:t>
             </a:r>
           </a:p>
           <a:p>
             <a:pPr lvl="3"/>
             <a:r>
-              <a:rPr lang="en-US"/>
+              <a:rPr lang="en-US" smtClean="0"/>
               <a:t>Fourth level</a:t>
             </a:r>
           </a:p>
           <a:p>
             <a:pPr lvl="4"/>
             <a:r>
-              <a:rPr lang="en-US"/>
+              <a:rPr lang="en-US" smtClean="0"/>
               <a:t>Fifth level</a:t>
             </a:r>
+            <a:endParaRPr lang="en-US"/>
           </a:p>
         </p:txBody>
       </p:sp>
@@ -662,7 +652,7 @@
           <a:p>
             <a:fld id="{5BCAD085-E8A6-8845-BD4E-CB4CCA059FC4}" type="datetimeFigureOut">
               <a:rPr lang="en-US" smtClean="0"/>
-              <a:t>10/12/2026</a:t>
+              <a:t>1/27/13</a:t>
             </a:fld>
             <a:endParaRPr lang="en-US"/>
           </a:p>
@@ -756,9 +746,10 @@
           <a:lstStyle/>
           <a:p>
             <a:r>
-              <a:rPr lang="en-US"/>
+              <a:rPr lang="en-US" smtClean="0"/>
               <a:t>Click to edit Master title style</a:t>
             </a:r>
+            <a:endParaRPr lang="en-US"/>
           </a:p>
         </p:txBody>
       </p:sp>
@@ -779,37 +770,38 @@
           <a:p>
             <a:pPr lvl="0"/>
             <a:r>
-              <a:rPr lang="en-US"/>
+              <a:rPr lang="en-US" smtClean="0"/>
               <a:t>Click to edit Master text styles</a:t>
             </a:r>
           </a:p>
           <a:p>
             <a:pPr lvl="1"/>
             <a:r>
-              <a:rPr lang="en-US"/>
+              <a:rPr lang="en-US" smtClean="0"/>
               <a:t>Second level</a:t>
             </a:r>
           </a:p>
           <a:p>
             <a:pPr lvl="2"/>
             <a:r>
-              <a:rPr lang="en-US"/>
+              <a:rPr lang="en-US" smtClean="0"/>
               <a:t>Third level</a:t>
             </a:r>
           </a:p>
           <a:p>
             <a:pPr lvl="3"/>
             <a:r>
-              <a:rPr lang="en-US"/>
+              <a:rPr lang="en-US" smtClean="0"/>
               <a:t>Fourth level</a:t>
             </a:r>
           </a:p>
           <a:p>
             <a:pPr lvl="4"/>
             <a:r>
-              <a:rPr lang="en-US"/>
+              <a:rPr lang="en-US" smtClean="0"/>
               <a:t>Fifth level</a:t>
             </a:r>
+            <a:endParaRPr lang="en-US"/>
           </a:p>
         </p:txBody>
       </p:sp>
@@ -830,7 +822,7 @@
           <a:p>
             <a:fld id="{5BCAD085-E8A6-8845-BD4E-CB4CCA059FC4}" type="datetimeFigureOut">
               <a:rPr lang="en-US" smtClean="0"/>
-              <a:t>10/12/2026</a:t>
+              <a:t>1/27/13</a:t>
             </a:fld>
             <a:endParaRPr lang="en-US"/>
           </a:p>
@@ -933,9 +925,10 @@
           </a:lstStyle>
           <a:p>
             <a:r>
-              <a:rPr lang="en-US"/>
+              <a:rPr lang="en-US" smtClean="0"/>
               <a:t>Click to edit Master title style</a:t>
             </a:r>
+            <a:endParaRPr lang="en-US"/>
           </a:p>
         </p:txBody>
       </p:sp>
@@ -1052,7 +1045,7 @@
           <a:p>
             <a:pPr lvl="0"/>
             <a:r>
-              <a:rPr lang="en-US"/>
+              <a:rPr lang="en-US" smtClean="0"/>
               <a:t>Click to edit Master text styles</a:t>
             </a:r>
           </a:p>
@@ -1075,7 +1068,7 @@
           <a:p>
             <a:fld id="{5BCAD085-E8A6-8845-BD4E-CB4CCA059FC4}" type="datetimeFigureOut">
               <a:rPr lang="en-US" smtClean="0"/>
-              <a:t>10/12/2026</a:t>
+              <a:t>1/27/13</a:t>
             </a:fld>
             <a:endParaRPr lang="en-US"/>
           </a:p>
@@ -1169,9 +1162,10 @@
           <a:lstStyle/>
           <a:p>
             <a:r>
-              <a:rPr lang="en-US"/>
+              <a:rPr lang="en-US" smtClean="0"/>
               <a:t>Click to edit Master title style</a:t>
             </a:r>
+            <a:endParaRPr lang="en-US"/>
           </a:p>
         </p:txBody>
       </p:sp>
@@ -1225,37 +1219,38 @@
           <a:p>
             <a:pPr lvl="0"/>
             <a:r>
-              <a:rPr lang="en-US"/>
+              <a:rPr lang="en-US" smtClean="0"/>
               <a:t>Click to edit Master text styles</a:t>
             </a:r>
           </a:p>
           <a:p>
             <a:pPr lvl="1"/>
             <a:r>
-              <a:rPr lang="en-US"/>
+              <a:rPr lang="en-US" smtClean="0"/>
               <a:t>Second level</a:t>
             </a:r>
           </a:p>
           <a:p>
             <a:pPr lvl="2"/>
             <a:r>
-              <a:rPr lang="en-US"/>
+              <a:rPr lang="en-US" smtClean="0"/>
               <a:t>Third level</a:t>
             </a:r>
           </a:p>
           <a:p>
             <a:pPr lvl="3"/>
             <a:r>
-              <a:rPr lang="en-US"/>
+              <a:rPr lang="en-US" smtClean="0"/>
               <a:t>Fourth level</a:t>
             </a:r>
           </a:p>
           <a:p>
             <a:pPr lvl="4"/>
             <a:r>
-              <a:rPr lang="en-US"/>
+              <a:rPr lang="en-US" smtClean="0"/>
               <a:t>Fifth level</a:t>
             </a:r>
+            <a:endParaRPr lang="en-US"/>
           </a:p>
         </p:txBody>
       </p:sp>
@@ -1309,37 +1304,38 @@
           <a:p>
             <a:pPr lvl="0"/>
             <a:r>
-              <a:rPr lang="en-US"/>
+              <a:rPr lang="en-US" smtClean="0"/>
               <a:t>Click to edit Master text styles</a:t>
             </a:r>
           </a:p>
           <a:p>
             <a:pPr lvl="1"/>
             <a:r>
-              <a:rPr lang="en-US"/>
+              <a:rPr lang="en-US" smtClean="0"/>
               <a:t>Second level</a:t>
             </a:r>
           </a:p>
           <a:p>
             <a:pPr lvl="2"/>
             <a:r>
-              <a:rPr lang="en-US"/>
+              <a:rPr lang="en-US" smtClean="0"/>
               <a:t>Third level</a:t>
             </a:r>
           </a:p>
           <a:p>
             <a:pPr lvl="3"/>
             <a:r>
-              <a:rPr lang="en-US"/>
+              <a:rPr lang="en-US" smtClean="0"/>
               <a:t>Fourth level</a:t>
             </a:r>
           </a:p>
           <a:p>
             <a:pPr lvl="4"/>
             <a:r>
-              <a:rPr lang="en-US"/>
+              <a:rPr lang="en-US" smtClean="0"/>
               <a:t>Fifth level</a:t>
             </a:r>
+            <a:endParaRPr lang="en-US"/>
           </a:p>
         </p:txBody>
       </p:sp>
@@ -1360,7 +1356,7 @@
           <a:p>
             <a:fld id="{5BCAD085-E8A6-8845-BD4E-CB4CCA059FC4}" type="datetimeFigureOut">
               <a:rPr lang="en-US" smtClean="0"/>
-              <a:t>10/12/2026</a:t>
+              <a:t>1/27/13</a:t>
             </a:fld>
             <a:endParaRPr lang="en-US"/>
           </a:p>
@@ -1458,9 +1454,10 @@
           </a:lstStyle>
           <a:p>
             <a:r>
-              <a:rPr lang="en-US"/>
+              <a:rPr lang="en-US" smtClean="0"/>
               <a:t>Click to edit Master title style</a:t>
             </a:r>
+            <a:endParaRPr lang="en-US"/>
           </a:p>
         </p:txBody>
       </p:sp>
@@ -1523,7 +1520,7 @@
           <a:p>
             <a:pPr lvl="0"/>
             <a:r>
-              <a:rPr lang="en-US"/>
+              <a:rPr lang="en-US" smtClean="0"/>
               <a:t>Click to edit Master text styles</a:t>
             </a:r>
           </a:p>
@@ -1579,37 +1576,38 @@
           <a:p>
             <a:pPr lvl="0"/>
             <a:r>
-              <a:rPr lang="en-US"/>
+              <a:rPr lang="en-US" smtClean="0"/>
               <a:t>Click to edit Master text styles</a:t>
             </a:r>
           </a:p>
           <a:p>
             <a:pPr lvl="1"/>
             <a:r>
-              <a:rPr lang="en-US"/>
+              <a:rPr lang="en-US" smtClean="0"/>
               <a:t>Second level</a:t>
             </a:r>
           </a:p>
           <a:p>
             <a:pPr lvl="2"/>
             <a:r>
-              <a:rPr lang="en-US"/>
+              <a:rPr lang="en-US" smtClean="0"/>
               <a:t>Third level</a:t>
             </a:r>
           </a:p>
           <a:p>
             <a:pPr lvl="3"/>
             <a:r>
-              <a:rPr lang="en-US"/>
+              <a:rPr lang="en-US" smtClean="0"/>
               <a:t>Fourth level</a:t>
             </a:r>
           </a:p>
           <a:p>
             <a:pPr lvl="4"/>
             <a:r>
-              <a:rPr lang="en-US"/>
+              <a:rPr lang="en-US" smtClean="0"/>
               <a:t>Fifth level</a:t>
             </a:r>
+            <a:endParaRPr lang="en-US"/>
           </a:p>
         </p:txBody>
       </p:sp>
@@ -1672,7 +1670,7 @@
           <a:p>
             <a:pPr lvl="0"/>
             <a:r>
-              <a:rPr lang="en-US"/>
+              <a:rPr lang="en-US" smtClean="0"/>
               <a:t>Click to edit Master text styles</a:t>
             </a:r>
           </a:p>
@@ -1728,37 +1726,38 @@
           <a:p>
             <a:pPr lvl="0"/>
             <a:r>
-              <a:rPr lang="en-US"/>
+              <a:rPr lang="en-US" smtClean="0"/>
               <a:t>Click to edit Master text styles</a:t>
             </a:r>
           </a:p>
           <a:p>
             <a:pPr lvl="1"/>
             <a:r>
-              <a:rPr lang="en-US"/>
+              <a:rPr lang="en-US" smtClean="0"/>
               <a:t>Second level</a:t>
             </a:r>
           </a:p>
           <a:p>
             <a:pPr lvl="2"/>
             <a:r>
-              <a:rPr lang="en-US"/>
+              <a:rPr lang="en-US" smtClean="0"/>
               <a:t>Third level</a:t>
             </a:r>
           </a:p>
           <a:p>
             <a:pPr lvl="3"/>
             <a:r>
-              <a:rPr lang="en-US"/>
+              <a:rPr lang="en-US" smtClean="0"/>
               <a:t>Fourth level</a:t>
             </a:r>
           </a:p>
           <a:p>
             <a:pPr lvl="4"/>
             <a:r>
-              <a:rPr lang="en-US"/>
+              <a:rPr lang="en-US" smtClean="0"/>
               <a:t>Fifth level</a:t>
             </a:r>
+            <a:endParaRPr lang="en-US"/>
           </a:p>
         </p:txBody>
       </p:sp>
@@ -1779,7 +1778,7 @@
           <a:p>
             <a:fld id="{5BCAD085-E8A6-8845-BD4E-CB4CCA059FC4}" type="datetimeFigureOut">
               <a:rPr lang="en-US" smtClean="0"/>
-              <a:t>10/12/2026</a:t>
+              <a:t>1/27/13</a:t>
             </a:fld>
             <a:endParaRPr lang="en-US"/>
           </a:p>
@@ -1873,9 +1872,10 @@
           <a:lstStyle/>
           <a:p>
             <a:r>
-              <a:rPr lang="en-US"/>
+              <a:rPr lang="en-US" smtClean="0"/>
               <a:t>Click to edit Master title style</a:t>
             </a:r>
+            <a:endParaRPr lang="en-US"/>
           </a:p>
         </p:txBody>
       </p:sp>
@@ -1896,7 +1896,7 @@
           <a:p>
             <a:fld id="{5BCAD085-E8A6-8845-BD4E-CB4CCA059FC4}" type="datetimeFigureOut">
               <a:rPr lang="en-US" smtClean="0"/>
-              <a:t>10/12/2026</a:t>
+              <a:t>1/27/13</a:t>
             </a:fld>
             <a:endParaRPr lang="en-US"/>
           </a:p>
@@ -1991,7 +1991,7 @@
           <a:p>
             <a:fld id="{5BCAD085-E8A6-8845-BD4E-CB4CCA059FC4}" type="datetimeFigureOut">
               <a:rPr lang="en-US" smtClean="0"/>
-              <a:t>10/12/2026</a:t>
+              <a:t>1/27/13</a:t>
             </a:fld>
             <a:endParaRPr lang="en-US"/>
           </a:p>
@@ -2094,9 +2094,10 @@
           </a:lstStyle>
           <a:p>
             <a:r>
-              <a:rPr lang="en-US"/>
+              <a:rPr lang="en-US" smtClean="0"/>
               <a:t>Click to edit Master title style</a:t>
             </a:r>
+            <a:endParaRPr lang="en-US"/>
           </a:p>
         </p:txBody>
       </p:sp>
@@ -2150,37 +2151,38 @@
           <a:p>
             <a:pPr lvl="0"/>
             <a:r>
-              <a:rPr lang="en-US"/>
+              <a:rPr lang="en-US" smtClean="0"/>
               <a:t>Click to edit Master text styles</a:t>
             </a:r>
           </a:p>
           <a:p>
             <a:pPr lvl="1"/>
             <a:r>
-              <a:rPr lang="en-US"/>
+              <a:rPr lang="en-US" smtClean="0"/>
               <a:t>Second level</a:t>
             </a:r>
           </a:p>
           <a:p>
             <a:pPr lvl="2"/>
             <a:r>
-              <a:rPr lang="en-US"/>
+              <a:rPr lang="en-US" smtClean="0"/>
               <a:t>Third level</a:t>
             </a:r>
           </a:p>
           <a:p>
             <a:pPr lvl="3"/>
             <a:r>
-              <a:rPr lang="en-US"/>
+              <a:rPr lang="en-US" smtClean="0"/>
               <a:t>Fourth level</a:t>
             </a:r>
           </a:p>
           <a:p>
             <a:pPr lvl="4"/>
             <a:r>
-              <a:rPr lang="en-US"/>
+              <a:rPr lang="en-US" smtClean="0"/>
               <a:t>Fifth level</a:t>
             </a:r>
+            <a:endParaRPr lang="en-US"/>
           </a:p>
         </p:txBody>
       </p:sp>
@@ -2243,7 +2245,7 @@
           <a:p>
             <a:pPr lvl="0"/>
             <a:r>
-              <a:rPr lang="en-US"/>
+              <a:rPr lang="en-US" smtClean="0"/>
               <a:t>Click to edit Master text styles</a:t>
             </a:r>
           </a:p>
@@ -2266,7 +2268,7 @@
           <a:p>
             <a:fld id="{5BCAD085-E8A6-8845-BD4E-CB4CCA059FC4}" type="datetimeFigureOut">
               <a:rPr lang="en-US" smtClean="0"/>
-              <a:t>10/12/2026</a:t>
+              <a:t>1/27/13</a:t>
             </a:fld>
             <a:endParaRPr lang="en-US"/>
           </a:p>
@@ -2369,9 +2371,10 @@
           </a:lstStyle>
           <a:p>
             <a:r>
-              <a:rPr lang="en-US"/>
+              <a:rPr lang="en-US" smtClean="0"/>
               <a:t>Click to edit Master title style</a:t>
             </a:r>
+            <a:endParaRPr lang="en-US"/>
           </a:p>
         </p:txBody>
       </p:sp>
@@ -2495,7 +2498,7 @@
           <a:p>
             <a:pPr lvl="0"/>
             <a:r>
-              <a:rPr lang="en-US"/>
+              <a:rPr lang="en-US" smtClean="0"/>
               <a:t>Click to edit Master text styles</a:t>
             </a:r>
           </a:p>
@@ -2518,7 +2521,7 @@
           <a:p>
             <a:fld id="{5BCAD085-E8A6-8845-BD4E-CB4CCA059FC4}" type="datetimeFigureOut">
               <a:rPr lang="en-US" smtClean="0"/>
-              <a:t>10/12/2026</a:t>
+              <a:t>1/27/13</a:t>
             </a:fld>
             <a:endParaRPr lang="en-US"/>
           </a:p>
@@ -2627,9 +2630,10 @@
           <a:lstStyle/>
           <a:p>
             <a:r>
-              <a:rPr lang="en-US"/>
+              <a:rPr lang="en-US" smtClean="0"/>
               <a:t>Click to edit Master title style</a:t>
             </a:r>
+            <a:endParaRPr lang="en-US"/>
           </a:p>
         </p:txBody>
       </p:sp>
@@ -2660,37 +2664,38 @@
           <a:p>
             <a:pPr lvl="0"/>
             <a:r>
-              <a:rPr lang="en-US"/>
+              <a:rPr lang="en-US" smtClean="0"/>
               <a:t>Click to edit Master text styles</a:t>
             </a:r>
           </a:p>
           <a:p>
             <a:pPr lvl="1"/>
             <a:r>
-              <a:rPr lang="en-US"/>
+              <a:rPr lang="en-US" smtClean="0"/>
               <a:t>Second level</a:t>
             </a:r>
           </a:p>
           <a:p>
             <a:pPr lvl="2"/>
             <a:r>
-              <a:rPr lang="en-US"/>
+              <a:rPr lang="en-US" smtClean="0"/>
               <a:t>Third level</a:t>
             </a:r>
           </a:p>
           <a:p>
             <a:pPr lvl="3"/>
             <a:r>
-              <a:rPr lang="en-US"/>
+              <a:rPr lang="en-US" smtClean="0"/>
               <a:t>Fourth level</a:t>
             </a:r>
           </a:p>
           <a:p>
             <a:pPr lvl="4"/>
             <a:r>
-              <a:rPr lang="en-US"/>
+              <a:rPr lang="en-US" smtClean="0"/>
               <a:t>Fifth level</a:t>
             </a:r>
+            <a:endParaRPr lang="en-US"/>
           </a:p>
         </p:txBody>
       </p:sp>
@@ -2729,7 +2734,7 @@
           <a:p>
             <a:fld id="{5BCAD085-E8A6-8845-BD4E-CB4CCA059FC4}" type="datetimeFigureOut">
               <a:rPr lang="en-US" smtClean="0"/>
-              <a:t>10/12/2026</a:t>
+              <a:t>1/27/13</a:t>
             </a:fld>
             <a:endParaRPr lang="en-US"/>
           </a:p>
@@ -3088,7 +3093,7 @@
 </file>
 
 <file path=ppt/slides/slide1.xml><?xml version="1.0" encoding="utf-8"?>
-<p:sld xmlns:a="http://schemas.openxmlformats.org/drawingml/2006/main" xmlns:r="http://schemas.openxmlformats.org/officeDocument/2006/relationships" xmlns:p="http://schemas.openxmlformats.org/presentationml/2006/main">
+<p:sld xmlns:a="http://schemas.openxmlformats.org/drawingml/2006/main" xmlns:p="http://schemas.openxmlformats.org/presentationml/2006/main" xmlns:r="http://schemas.openxmlformats.org/officeDocument/2006/relationships">
   <p:cSld>
     <p:spTree>
       <p:nvGrpSpPr>
@@ -3096,14 +3101,7 @@
         <p:cNvGrpSpPr/>
         <p:nvPr/>
       </p:nvGrpSpPr>
-      <p:grpSpPr>
-        <a:xfrm>
-          <a:off x="0" y="0"/>
-          <a:ext cx="0" cy="0"/>
-          <a:chOff x="0" y="0"/>
-          <a:chExt cx="0" cy="0"/>
-        </a:xfrm>
-      </p:grpSpPr>
+      <p:grpSpPr/>
       <p:sp>
         <p:nvSpPr>
           <p:cNvPr id="2" name="Rectangle 1"/>
@@ -3145,7 +3143,6 @@
           <a:lstStyle/>
           <a:p>
             <a:pPr algn="ctr"/>
-            <a:endParaRPr/>
           </a:p>
         </p:txBody>
       </p:sp>
@@ -3190,7 +3187,6 @@
           <a:lstStyle/>
           <a:p>
             <a:pPr algn="ctr"/>
-            <a:endParaRPr/>
           </a:p>
         </p:txBody>
       </p:sp>
@@ -3294,7 +3290,6 @@
           <a:lstStyle/>
           <a:p>
             <a:pPr algn="ctr"/>
-            <a:endParaRPr/>
           </a:p>
         </p:txBody>
       </p:sp>
@@ -3456,7 +3451,6 @@
           <a:lstStyle/>
           <a:p>
             <a:pPr algn="ctr"/>
-            <a:endParaRPr/>
           </a:p>
         </p:txBody>
       </p:sp>
@@ -3469,7 +3463,7 @@
 </file>
 
 <file path=ppt/slides/slide10.xml><?xml version="1.0" encoding="utf-8"?>
-<p:sld xmlns:a="http://schemas.openxmlformats.org/drawingml/2006/main" xmlns:r="http://schemas.openxmlformats.org/officeDocument/2006/relationships" xmlns:p="http://schemas.openxmlformats.org/presentationml/2006/main">
+<p:sld xmlns:a="http://schemas.openxmlformats.org/drawingml/2006/main" xmlns:p="http://schemas.openxmlformats.org/presentationml/2006/main" xmlns:r="http://schemas.openxmlformats.org/officeDocument/2006/relationships">
   <p:cSld>
     <p:spTree>
       <p:nvGrpSpPr>
@@ -3477,14 +3471,7 @@
         <p:cNvGrpSpPr/>
         <p:nvPr/>
       </p:nvGrpSpPr>
-      <p:grpSpPr>
-        <a:xfrm>
-          <a:off x="0" y="0"/>
-          <a:ext cx="0" cy="0"/>
-          <a:chOff x="0" y="0"/>
-          <a:chExt cx="0" cy="0"/>
-        </a:xfrm>
-      </p:grpSpPr>
+      <p:grpSpPr/>
       <p:sp>
         <p:nvSpPr>
           <p:cNvPr id="2" name="Rectangle 1"/>
@@ -3526,7 +3513,6 @@
           <a:lstStyle/>
           <a:p>
             <a:pPr algn="ctr"/>
-            <a:endParaRPr/>
           </a:p>
         </p:txBody>
       </p:sp>
@@ -3571,7 +3557,6 @@
           <a:lstStyle/>
           <a:p>
             <a:pPr algn="ctr"/>
-            <a:endParaRPr/>
           </a:p>
         </p:txBody>
       </p:sp>
@@ -3651,7 +3636,6 @@
           <a:lstStyle/>
           <a:p>
             <a:pPr algn="ctr"/>
-            <a:endParaRPr/>
           </a:p>
         </p:txBody>
       </p:sp>
@@ -3955,7 +3939,7 @@
 </file>
 
 <file path=ppt/slides/slide11.xml><?xml version="1.0" encoding="utf-8"?>
-<p:sld xmlns:a="http://schemas.openxmlformats.org/drawingml/2006/main" xmlns:r="http://schemas.openxmlformats.org/officeDocument/2006/relationships" xmlns:p="http://schemas.openxmlformats.org/presentationml/2006/main">
+<p:sld xmlns:a="http://schemas.openxmlformats.org/drawingml/2006/main" xmlns:p="http://schemas.openxmlformats.org/presentationml/2006/main" xmlns:r="http://schemas.openxmlformats.org/officeDocument/2006/relationships">
   <p:cSld>
     <p:spTree>
       <p:nvGrpSpPr>
@@ -3963,14 +3947,7 @@
         <p:cNvGrpSpPr/>
         <p:nvPr/>
       </p:nvGrpSpPr>
-      <p:grpSpPr>
-        <a:xfrm>
-          <a:off x="0" y="0"/>
-          <a:ext cx="0" cy="0"/>
-          <a:chOff x="0" y="0"/>
-          <a:chExt cx="0" cy="0"/>
-        </a:xfrm>
-      </p:grpSpPr>
+      <p:grpSpPr/>
       <p:sp>
         <p:nvSpPr>
           <p:cNvPr id="2" name="Rectangle 1"/>
@@ -4012,7 +3989,6 @@
           <a:lstStyle/>
           <a:p>
             <a:pPr algn="ctr"/>
-            <a:endParaRPr/>
           </a:p>
         </p:txBody>
       </p:sp>
@@ -4057,7 +4033,6 @@
           <a:lstStyle/>
           <a:p>
             <a:pPr algn="ctr"/>
-            <a:endParaRPr/>
           </a:p>
         </p:txBody>
       </p:sp>
@@ -4137,7 +4112,6 @@
           <a:lstStyle/>
           <a:p>
             <a:pPr algn="ctr"/>
-            <a:endParaRPr/>
           </a:p>
         </p:txBody>
       </p:sp>
@@ -4299,7 +4273,7 @@
                 </a:solidFill>
                 <a:latin typeface="Arial"/>
               </a:rPr>
-              <a:t>   Mỗi thiết bị đăng nhập mới phải được một thiết bị đang hoạt động phê duyệt, hoặc xác nhận qua mã OTP gửi email — ngăn đăng nhập trái phép kể cả khi lộ khóa.</a:t>
+              <a:t>   Thiết bị mới phải được một thiết bị đang hoạt động duyệt, hoặc OTP về email khi không còn máy nào online — mỗi phiên ghi nhãn trình duyệt kèm phiên bản, IP và User-Agent để chủ ví nhận diện máy lạ. Khi mất hết neo tin cậy, cơ chế chờ 24 giờ giữ cho ví không bị khóa vĩnh viễn.</a:t>
             </a:r>
           </a:p>
         </p:txBody>
@@ -4441,7 +4415,7 @@
 </file>
 
 <file path=ppt/slides/slide12.xml><?xml version="1.0" encoding="utf-8"?>
-<p:sld xmlns:a="http://schemas.openxmlformats.org/drawingml/2006/main" xmlns:r="http://schemas.openxmlformats.org/officeDocument/2006/relationships" xmlns:p="http://schemas.openxmlformats.org/presentationml/2006/main">
+<p:sld xmlns:a="http://schemas.openxmlformats.org/drawingml/2006/main" xmlns:p="http://schemas.openxmlformats.org/presentationml/2006/main" xmlns:r="http://schemas.openxmlformats.org/officeDocument/2006/relationships">
   <p:cSld>
     <p:spTree>
       <p:nvGrpSpPr>
@@ -4449,14 +4423,7 @@
         <p:cNvGrpSpPr/>
         <p:nvPr/>
       </p:nvGrpSpPr>
-      <p:grpSpPr>
-        <a:xfrm>
-          <a:off x="0" y="0"/>
-          <a:ext cx="0" cy="0"/>
-          <a:chOff x="0" y="0"/>
-          <a:chExt cx="0" cy="0"/>
-        </a:xfrm>
-      </p:grpSpPr>
+      <p:grpSpPr/>
       <p:sp>
         <p:nvSpPr>
           <p:cNvPr id="2" name="Rectangle 1"/>
@@ -4498,7 +4465,6 @@
           <a:lstStyle/>
           <a:p>
             <a:pPr algn="ctr"/>
-            <a:endParaRPr/>
           </a:p>
         </p:txBody>
       </p:sp>
@@ -4543,7 +4509,6 @@
           <a:lstStyle/>
           <a:p>
             <a:pPr algn="ctr"/>
-            <a:endParaRPr/>
           </a:p>
         </p:txBody>
       </p:sp>
@@ -4623,7 +4588,6 @@
           <a:lstStyle/>
           <a:p>
             <a:pPr algn="ctr"/>
-            <a:endParaRPr/>
           </a:p>
         </p:txBody>
       </p:sp>
@@ -5092,7 +5056,7 @@
                 </a:solidFill>
                 <a:latin typeface="Arial"/>
               </a:rPr>
-              <a:t>   Chữ ký ví thay mật khẩu, phiên JWT có thời hạn, phê duyệt thiết bị bằng OTP, phân quyền ngay trong contract, mã hóa AES-256 phía client và bọc khóa bằng khóa chủ phía server.</a:t>
+              <a:t>   Chữ ký ví thay mật khẩu, phiên JWT có thời hạn, duyệt thiết bị từ máy cũ kèm nhận diện IP–trình duyệt, OTP email làm đường cứu, phân quyền ngay trong contract, mã hóa AES-256 phía client và bọc khóa bằng khóa chủ phía server.</a:t>
             </a:r>
           </a:p>
         </p:txBody>
@@ -5106,7 +5070,7 @@
 </file>
 
 <file path=ppt/slides/slide13.xml><?xml version="1.0" encoding="utf-8"?>
-<p:sld xmlns:a="http://schemas.openxmlformats.org/drawingml/2006/main" xmlns:r="http://schemas.openxmlformats.org/officeDocument/2006/relationships" xmlns:p="http://schemas.openxmlformats.org/presentationml/2006/main">
+<p:sld xmlns:a="http://schemas.openxmlformats.org/drawingml/2006/main" xmlns:p="http://schemas.openxmlformats.org/presentationml/2006/main" xmlns:r="http://schemas.openxmlformats.org/officeDocument/2006/relationships">
   <p:cSld>
     <p:spTree>
       <p:nvGrpSpPr>
@@ -5114,14 +5078,7 @@
         <p:cNvGrpSpPr/>
         <p:nvPr/>
       </p:nvGrpSpPr>
-      <p:grpSpPr>
-        <a:xfrm>
-          <a:off x="0" y="0"/>
-          <a:ext cx="0" cy="0"/>
-          <a:chOff x="0" y="0"/>
-          <a:chExt cx="0" cy="0"/>
-        </a:xfrm>
-      </p:grpSpPr>
+      <p:grpSpPr/>
       <p:sp>
         <p:nvSpPr>
           <p:cNvPr id="2" name="Rectangle 1"/>
@@ -5163,7 +5120,6 @@
           <a:lstStyle/>
           <a:p>
             <a:pPr algn="ctr"/>
-            <a:endParaRPr/>
           </a:p>
         </p:txBody>
       </p:sp>
@@ -5208,7 +5164,6 @@
           <a:lstStyle/>
           <a:p>
             <a:pPr algn="ctr"/>
-            <a:endParaRPr/>
           </a:p>
         </p:txBody>
       </p:sp>
@@ -5288,7 +5243,6 @@
           <a:lstStyle/>
           <a:p>
             <a:pPr algn="ctr"/>
-            <a:endParaRPr/>
           </a:p>
         </p:txBody>
       </p:sp>
@@ -5864,7 +5818,7 @@
 </file>
 
 <file path=ppt/slides/slide14.xml><?xml version="1.0" encoding="utf-8"?>
-<p:sld xmlns:a="http://schemas.openxmlformats.org/drawingml/2006/main" xmlns:r="http://schemas.openxmlformats.org/officeDocument/2006/relationships" xmlns:p="http://schemas.openxmlformats.org/presentationml/2006/main">
+<p:sld xmlns:a="http://schemas.openxmlformats.org/drawingml/2006/main" xmlns:p="http://schemas.openxmlformats.org/presentationml/2006/main" xmlns:r="http://schemas.openxmlformats.org/officeDocument/2006/relationships">
   <p:cSld>
     <p:spTree>
       <p:nvGrpSpPr>
@@ -5872,14 +5826,7 @@
         <p:cNvGrpSpPr/>
         <p:nvPr/>
       </p:nvGrpSpPr>
-      <p:grpSpPr>
-        <a:xfrm>
-          <a:off x="0" y="0"/>
-          <a:ext cx="0" cy="0"/>
-          <a:chOff x="0" y="0"/>
-          <a:chExt cx="0" cy="0"/>
-        </a:xfrm>
-      </p:grpSpPr>
+      <p:grpSpPr/>
       <p:sp>
         <p:nvSpPr>
           <p:cNvPr id="2" name="Rectangle 1"/>
@@ -5921,7 +5868,6 @@
           <a:lstStyle/>
           <a:p>
             <a:pPr algn="ctr"/>
-            <a:endParaRPr/>
           </a:p>
         </p:txBody>
       </p:sp>
@@ -5966,7 +5912,6 @@
           <a:lstStyle/>
           <a:p>
             <a:pPr algn="ctr"/>
-            <a:endParaRPr/>
           </a:p>
         </p:txBody>
       </p:sp>
@@ -6046,7 +5991,6 @@
           <a:lstStyle/>
           <a:p>
             <a:pPr algn="ctr"/>
-            <a:endParaRPr/>
           </a:p>
         </p:txBody>
       </p:sp>
@@ -6280,7 +6224,7 @@
 </file>
 
 <file path=ppt/slides/slide15.xml><?xml version="1.0" encoding="utf-8"?>
-<p:sld xmlns:a="http://schemas.openxmlformats.org/drawingml/2006/main" xmlns:r="http://schemas.openxmlformats.org/officeDocument/2006/relationships" xmlns:p="http://schemas.openxmlformats.org/presentationml/2006/main">
+<p:sld xmlns:a="http://schemas.openxmlformats.org/drawingml/2006/main" xmlns:p="http://schemas.openxmlformats.org/presentationml/2006/main" xmlns:r="http://schemas.openxmlformats.org/officeDocument/2006/relationships">
   <p:cSld>
     <p:spTree>
       <p:nvGrpSpPr>
@@ -6288,14 +6232,7 @@
         <p:cNvGrpSpPr/>
         <p:nvPr/>
       </p:nvGrpSpPr>
-      <p:grpSpPr>
-        <a:xfrm>
-          <a:off x="0" y="0"/>
-          <a:ext cx="0" cy="0"/>
-          <a:chOff x="0" y="0"/>
-          <a:chExt cx="0" cy="0"/>
-        </a:xfrm>
-      </p:grpSpPr>
+      <p:grpSpPr/>
       <p:sp>
         <p:nvSpPr>
           <p:cNvPr id="2" name="Rectangle 1"/>
@@ -6337,7 +6274,6 @@
           <a:lstStyle/>
           <a:p>
             <a:pPr algn="ctr"/>
-            <a:endParaRPr/>
           </a:p>
         </p:txBody>
       </p:sp>
@@ -6382,7 +6318,6 @@
           <a:lstStyle/>
           <a:p>
             <a:pPr algn="ctr"/>
-            <a:endParaRPr/>
           </a:p>
         </p:txBody>
       </p:sp>
@@ -6462,7 +6397,6 @@
           <a:lstStyle/>
           <a:p>
             <a:pPr algn="ctr"/>
-            <a:endParaRPr/>
           </a:p>
         </p:txBody>
       </p:sp>
@@ -6542,7 +6476,6 @@
           <a:lstStyle/>
           <a:p>
             <a:pPr algn="ctr"/>
-            <a:endParaRPr/>
           </a:p>
         </p:txBody>
       </p:sp>
@@ -6555,7 +6488,7 @@
 </file>
 
 <file path=ppt/slides/slide2.xml><?xml version="1.0" encoding="utf-8"?>
-<p:sld xmlns:a="http://schemas.openxmlformats.org/drawingml/2006/main" xmlns:r="http://schemas.openxmlformats.org/officeDocument/2006/relationships" xmlns:p="http://schemas.openxmlformats.org/presentationml/2006/main">
+<p:sld xmlns:a="http://schemas.openxmlformats.org/drawingml/2006/main" xmlns:p="http://schemas.openxmlformats.org/presentationml/2006/main" xmlns:r="http://schemas.openxmlformats.org/officeDocument/2006/relationships">
   <p:cSld>
     <p:spTree>
       <p:nvGrpSpPr>
@@ -6563,14 +6496,7 @@
         <p:cNvGrpSpPr/>
         <p:nvPr/>
       </p:nvGrpSpPr>
-      <p:grpSpPr>
-        <a:xfrm>
-          <a:off x="0" y="0"/>
-          <a:ext cx="0" cy="0"/>
-          <a:chOff x="0" y="0"/>
-          <a:chExt cx="0" cy="0"/>
-        </a:xfrm>
-      </p:grpSpPr>
+      <p:grpSpPr/>
       <p:sp>
         <p:nvSpPr>
           <p:cNvPr id="2" name="Rectangle 1"/>
@@ -6612,7 +6538,6 @@
           <a:lstStyle/>
           <a:p>
             <a:pPr algn="ctr"/>
-            <a:endParaRPr/>
           </a:p>
         </p:txBody>
       </p:sp>
@@ -6657,7 +6582,6 @@
           <a:lstStyle/>
           <a:p>
             <a:pPr algn="ctr"/>
-            <a:endParaRPr/>
           </a:p>
         </p:txBody>
       </p:sp>
@@ -6737,7 +6661,6 @@
           <a:lstStyle/>
           <a:p>
             <a:pPr algn="ctr"/>
-            <a:endParaRPr/>
           </a:p>
         </p:txBody>
       </p:sp>
@@ -6887,7 +6810,6 @@
           <a:lstStyle/>
           <a:p>
             <a:pPr algn="ctr"/>
-            <a:endParaRPr/>
           </a:p>
         </p:txBody>
       </p:sp>
@@ -7002,7 +6924,6 @@
           <a:lstStyle/>
           <a:p>
             <a:pPr algn="ctr"/>
-            <a:endParaRPr/>
           </a:p>
         </p:txBody>
       </p:sp>
@@ -7050,7 +6971,7 @@
         <p:spPr>
           <a:xfrm>
             <a:off x="1200000" y="5500000"/>
-            <a:ext cx="10000000" cy="1261884"/>
+            <a:ext cx="10000000" cy="1100000"/>
           </a:xfrm>
           <a:prstGeom prst="rect">
             <a:avLst/>
@@ -7097,21 +7018,6 @@
               </a:rPr>
               <a:t>Nguyễn Quang Huy — 22810310051</a:t>
             </a:r>
-            <a:endParaRPr lang="en-US" sz="1900" b="0" i="0">
-              <a:solidFill>
-                <a:srgbClr val="C9D8E4"/>
-              </a:solidFill>
-              <a:latin typeface="Arial"/>
-            </a:endParaRPr>
-          </a:p>
-          <a:p>
-            <a:pPr algn="l"/>
-            <a:endParaRPr sz="1900" b="0" i="0">
-              <a:solidFill>
-                <a:srgbClr val="C9D8E4"/>
-              </a:solidFill>
-              <a:latin typeface="Arial"/>
-            </a:endParaRPr>
           </a:p>
         </p:txBody>
       </p:sp>
@@ -7124,7 +7030,7 @@
 </file>
 
 <file path=ppt/slides/slide3.xml><?xml version="1.0" encoding="utf-8"?>
-<p:sld xmlns:a="http://schemas.openxmlformats.org/drawingml/2006/main" xmlns:r="http://schemas.openxmlformats.org/officeDocument/2006/relationships" xmlns:p="http://schemas.openxmlformats.org/presentationml/2006/main">
+<p:sld xmlns:a="http://schemas.openxmlformats.org/drawingml/2006/main" xmlns:p="http://schemas.openxmlformats.org/presentationml/2006/main" xmlns:r="http://schemas.openxmlformats.org/officeDocument/2006/relationships">
   <p:cSld>
     <p:spTree>
       <p:nvGrpSpPr>
@@ -7132,14 +7038,7 @@
         <p:cNvGrpSpPr/>
         <p:nvPr/>
       </p:nvGrpSpPr>
-      <p:grpSpPr>
-        <a:xfrm>
-          <a:off x="0" y="0"/>
-          <a:ext cx="0" cy="0"/>
-          <a:chOff x="0" y="0"/>
-          <a:chExt cx="0" cy="0"/>
-        </a:xfrm>
-      </p:grpSpPr>
+      <p:grpSpPr/>
       <p:sp>
         <p:nvSpPr>
           <p:cNvPr id="2" name="Rectangle 1"/>
@@ -7181,7 +7080,6 @@
           <a:lstStyle/>
           <a:p>
             <a:pPr algn="ctr"/>
-            <a:endParaRPr/>
           </a:p>
         </p:txBody>
       </p:sp>
@@ -7226,7 +7124,6 @@
           <a:lstStyle/>
           <a:p>
             <a:pPr algn="ctr"/>
-            <a:endParaRPr/>
           </a:p>
         </p:txBody>
       </p:sp>
@@ -7306,7 +7203,6 @@
           <a:lstStyle/>
           <a:p>
             <a:pPr algn="ctr"/>
-            <a:endParaRPr/>
           </a:p>
         </p:txBody>
       </p:sp>
@@ -7756,7 +7652,7 @@
 </file>
 
 <file path=ppt/slides/slide4.xml><?xml version="1.0" encoding="utf-8"?>
-<p:sld xmlns:a="http://schemas.openxmlformats.org/drawingml/2006/main" xmlns:r="http://schemas.openxmlformats.org/officeDocument/2006/relationships" xmlns:p="http://schemas.openxmlformats.org/presentationml/2006/main">
+<p:sld xmlns:a="http://schemas.openxmlformats.org/drawingml/2006/main" xmlns:p="http://schemas.openxmlformats.org/presentationml/2006/main" xmlns:r="http://schemas.openxmlformats.org/officeDocument/2006/relationships">
   <p:cSld>
     <p:spTree>
       <p:nvGrpSpPr>
@@ -7764,14 +7660,7 @@
         <p:cNvGrpSpPr/>
         <p:nvPr/>
       </p:nvGrpSpPr>
-      <p:grpSpPr>
-        <a:xfrm>
-          <a:off x="0" y="0"/>
-          <a:ext cx="0" cy="0"/>
-          <a:chOff x="0" y="0"/>
-          <a:chExt cx="0" cy="0"/>
-        </a:xfrm>
-      </p:grpSpPr>
+      <p:grpSpPr/>
       <p:sp>
         <p:nvSpPr>
           <p:cNvPr id="2" name="Rectangle 1"/>
@@ -7813,7 +7702,6 @@
           <a:lstStyle/>
           <a:p>
             <a:pPr algn="ctr"/>
-            <a:endParaRPr/>
           </a:p>
         </p:txBody>
       </p:sp>
@@ -7858,7 +7746,6 @@
           <a:lstStyle/>
           <a:p>
             <a:pPr algn="ctr"/>
-            <a:endParaRPr/>
           </a:p>
         </p:txBody>
       </p:sp>
@@ -7938,7 +7825,6 @@
           <a:lstStyle/>
           <a:p>
             <a:pPr algn="ctr"/>
-            <a:endParaRPr/>
           </a:p>
         </p:txBody>
       </p:sp>
@@ -8149,7 +8035,7 @@
 </file>
 
 <file path=ppt/slides/slide5.xml><?xml version="1.0" encoding="utf-8"?>
-<p:sld xmlns:a="http://schemas.openxmlformats.org/drawingml/2006/main" xmlns:r="http://schemas.openxmlformats.org/officeDocument/2006/relationships" xmlns:p="http://schemas.openxmlformats.org/presentationml/2006/main">
+<p:sld xmlns:a="http://schemas.openxmlformats.org/drawingml/2006/main" xmlns:p="http://schemas.openxmlformats.org/presentationml/2006/main" xmlns:r="http://schemas.openxmlformats.org/officeDocument/2006/relationships">
   <p:cSld>
     <p:spTree>
       <p:nvGrpSpPr>
@@ -8157,14 +8043,7 @@
         <p:cNvGrpSpPr/>
         <p:nvPr/>
       </p:nvGrpSpPr>
-      <p:grpSpPr>
-        <a:xfrm>
-          <a:off x="0" y="0"/>
-          <a:ext cx="0" cy="0"/>
-          <a:chOff x="0" y="0"/>
-          <a:chExt cx="0" cy="0"/>
-        </a:xfrm>
-      </p:grpSpPr>
+      <p:grpSpPr/>
       <p:sp>
         <p:nvSpPr>
           <p:cNvPr id="2" name="Rectangle 1"/>
@@ -8206,7 +8085,6 @@
           <a:lstStyle/>
           <a:p>
             <a:pPr algn="ctr"/>
-            <a:endParaRPr/>
           </a:p>
         </p:txBody>
       </p:sp>
@@ -8251,7 +8129,6 @@
           <a:lstStyle/>
           <a:p>
             <a:pPr algn="ctr"/>
-            <a:endParaRPr/>
           </a:p>
         </p:txBody>
       </p:sp>
@@ -8331,7 +8208,6 @@
           <a:lstStyle/>
           <a:p>
             <a:pPr algn="ctr"/>
-            <a:endParaRPr/>
           </a:p>
         </p:txBody>
       </p:sp>
@@ -8542,7 +8418,7 @@
 </file>
 
 <file path=ppt/slides/slide6.xml><?xml version="1.0" encoding="utf-8"?>
-<p:sld xmlns:a="http://schemas.openxmlformats.org/drawingml/2006/main" xmlns:r="http://schemas.openxmlformats.org/officeDocument/2006/relationships" xmlns:p="http://schemas.openxmlformats.org/presentationml/2006/main">
+<p:sld xmlns:a="http://schemas.openxmlformats.org/drawingml/2006/main" xmlns:p="http://schemas.openxmlformats.org/presentationml/2006/main" xmlns:r="http://schemas.openxmlformats.org/officeDocument/2006/relationships">
   <p:cSld>
     <p:spTree>
       <p:nvGrpSpPr>
@@ -8550,14 +8426,7 @@
         <p:cNvGrpSpPr/>
         <p:nvPr/>
       </p:nvGrpSpPr>
-      <p:grpSpPr>
-        <a:xfrm>
-          <a:off x="0" y="0"/>
-          <a:ext cx="0" cy="0"/>
-          <a:chOff x="0" y="0"/>
-          <a:chExt cx="0" cy="0"/>
-        </a:xfrm>
-      </p:grpSpPr>
+      <p:grpSpPr/>
       <p:sp>
         <p:nvSpPr>
           <p:cNvPr id="2" name="Rectangle 1"/>
@@ -8599,7 +8468,6 @@
           <a:lstStyle/>
           <a:p>
             <a:pPr algn="ctr"/>
-            <a:endParaRPr/>
           </a:p>
         </p:txBody>
       </p:sp>
@@ -8644,7 +8512,6 @@
           <a:lstStyle/>
           <a:p>
             <a:pPr algn="ctr"/>
-            <a:endParaRPr/>
           </a:p>
         </p:txBody>
       </p:sp>
@@ -8724,7 +8591,6 @@
           <a:lstStyle/>
           <a:p>
             <a:pPr algn="ctr"/>
-            <a:endParaRPr/>
           </a:p>
         </p:txBody>
       </p:sp>
@@ -8935,7 +8801,7 @@
 </file>
 
 <file path=ppt/slides/slide7.xml><?xml version="1.0" encoding="utf-8"?>
-<p:sld xmlns:a="http://schemas.openxmlformats.org/drawingml/2006/main" xmlns:r="http://schemas.openxmlformats.org/officeDocument/2006/relationships" xmlns:p="http://schemas.openxmlformats.org/presentationml/2006/main">
+<p:sld xmlns:a="http://schemas.openxmlformats.org/drawingml/2006/main" xmlns:p="http://schemas.openxmlformats.org/presentationml/2006/main" xmlns:r="http://schemas.openxmlformats.org/officeDocument/2006/relationships">
   <p:cSld>
     <p:spTree>
       <p:nvGrpSpPr>
@@ -8943,14 +8809,7 @@
         <p:cNvGrpSpPr/>
         <p:nvPr/>
       </p:nvGrpSpPr>
-      <p:grpSpPr>
-        <a:xfrm>
-          <a:off x="0" y="0"/>
-          <a:ext cx="0" cy="0"/>
-          <a:chOff x="0" y="0"/>
-          <a:chExt cx="0" cy="0"/>
-        </a:xfrm>
-      </p:grpSpPr>
+      <p:grpSpPr/>
       <p:sp>
         <p:nvSpPr>
           <p:cNvPr id="2" name="Rectangle 1"/>
@@ -8992,7 +8851,6 @@
           <a:lstStyle/>
           <a:p>
             <a:pPr algn="ctr"/>
-            <a:endParaRPr/>
           </a:p>
         </p:txBody>
       </p:sp>
@@ -9037,7 +8895,6 @@
           <a:lstStyle/>
           <a:p>
             <a:pPr algn="ctr"/>
-            <a:endParaRPr/>
           </a:p>
         </p:txBody>
       </p:sp>
@@ -9117,7 +8974,6 @@
           <a:lstStyle/>
           <a:p>
             <a:pPr algn="ctr"/>
-            <a:endParaRPr/>
           </a:p>
         </p:txBody>
       </p:sp>
@@ -9265,7 +9121,6 @@
           <a:lstStyle/>
           <a:p>
             <a:pPr algn="ctr"/>
-            <a:endParaRPr/>
           </a:p>
         </p:txBody>
       </p:sp>
@@ -9378,7 +9233,6 @@
           <a:lstStyle/>
           <a:p>
             <a:pPr algn="ctr"/>
-            <a:endParaRPr/>
           </a:p>
         </p:txBody>
       </p:sp>
@@ -9621,7 +9475,7 @@
 </file>
 
 <file path=ppt/slides/slide8.xml><?xml version="1.0" encoding="utf-8"?>
-<p:sld xmlns:a="http://schemas.openxmlformats.org/drawingml/2006/main" xmlns:r="http://schemas.openxmlformats.org/officeDocument/2006/relationships" xmlns:p="http://schemas.openxmlformats.org/presentationml/2006/main">
+<p:sld xmlns:a="http://schemas.openxmlformats.org/drawingml/2006/main" xmlns:p="http://schemas.openxmlformats.org/presentationml/2006/main" xmlns:r="http://schemas.openxmlformats.org/officeDocument/2006/relationships">
   <p:cSld>
     <p:spTree>
       <p:nvGrpSpPr>
@@ -9629,14 +9483,7 @@
         <p:cNvGrpSpPr/>
         <p:nvPr/>
       </p:nvGrpSpPr>
-      <p:grpSpPr>
-        <a:xfrm>
-          <a:off x="0" y="0"/>
-          <a:ext cx="0" cy="0"/>
-          <a:chOff x="0" y="0"/>
-          <a:chExt cx="0" cy="0"/>
-        </a:xfrm>
-      </p:grpSpPr>
+      <p:grpSpPr/>
       <p:sp>
         <p:nvSpPr>
           <p:cNvPr id="2" name="Rectangle 1"/>
@@ -9678,7 +9525,6 @@
           <a:lstStyle/>
           <a:p>
             <a:pPr algn="ctr"/>
-            <a:endParaRPr/>
           </a:p>
         </p:txBody>
       </p:sp>
@@ -9723,7 +9569,6 @@
           <a:lstStyle/>
           <a:p>
             <a:pPr algn="ctr"/>
-            <a:endParaRPr/>
           </a:p>
         </p:txBody>
       </p:sp>
@@ -9803,7 +9648,6 @@
           <a:lstStyle/>
           <a:p>
             <a:pPr algn="ctr"/>
-            <a:endParaRPr/>
           </a:p>
         </p:txBody>
       </p:sp>
@@ -10247,7 +10091,7 @@
 </file>
 
 <file path=ppt/slides/slide9.xml><?xml version="1.0" encoding="utf-8"?>
-<p:sld xmlns:a="http://schemas.openxmlformats.org/drawingml/2006/main" xmlns:r="http://schemas.openxmlformats.org/officeDocument/2006/relationships" xmlns:p="http://schemas.openxmlformats.org/presentationml/2006/main">
+<p:sld xmlns:a="http://schemas.openxmlformats.org/drawingml/2006/main" xmlns:p="http://schemas.openxmlformats.org/presentationml/2006/main" xmlns:r="http://schemas.openxmlformats.org/officeDocument/2006/relationships">
   <p:cSld>
     <p:spTree>
       <p:nvGrpSpPr>
@@ -10255,14 +10099,7 @@
         <p:cNvGrpSpPr/>
         <p:nvPr/>
       </p:nvGrpSpPr>
-      <p:grpSpPr>
-        <a:xfrm>
-          <a:off x="0" y="0"/>
-          <a:ext cx="0" cy="0"/>
-          <a:chOff x="0" y="0"/>
-          <a:chExt cx="0" cy="0"/>
-        </a:xfrm>
-      </p:grpSpPr>
+      <p:grpSpPr/>
       <p:sp>
         <p:nvSpPr>
           <p:cNvPr id="2" name="Rectangle 1"/>
@@ -10304,7 +10141,6 @@
           <a:lstStyle/>
           <a:p>
             <a:pPr algn="ctr"/>
-            <a:endParaRPr/>
           </a:p>
         </p:txBody>
       </p:sp>
@@ -10349,7 +10185,6 @@
           <a:lstStyle/>
           <a:p>
             <a:pPr algn="ctr"/>
-            <a:endParaRPr/>
           </a:p>
         </p:txBody>
       </p:sp>
@@ -10429,7 +10264,6 @@
           <a:lstStyle/>
           <a:p>
             <a:pPr algn="ctr"/>
-            <a:endParaRPr/>
           </a:p>
         </p:txBody>
       </p:sp>
@@ -10566,7 +10400,6 @@
           <a:lstStyle/>
           <a:p>
             <a:pPr algn="ctr"/>
-            <a:endParaRPr/>
           </a:p>
         </p:txBody>
       </p:sp>
@@ -10667,7 +10500,6 @@
           <a:lstStyle/>
           <a:p>
             <a:pPr algn="ctr"/>
-            <a:endParaRPr/>
           </a:p>
         </p:txBody>
       </p:sp>
@@ -10768,7 +10600,6 @@
           <a:lstStyle/>
           <a:p>
             <a:pPr algn="ctr"/>
-            <a:endParaRPr/>
           </a:p>
         </p:txBody>
       </p:sp>
@@ -10869,7 +10700,6 @@
           <a:lstStyle/>
           <a:p>
             <a:pPr algn="ctr"/>
-            <a:endParaRPr/>
           </a:p>
         </p:txBody>
       </p:sp>
@@ -10970,7 +10800,6 @@
           <a:lstStyle/>
           <a:p>
             <a:pPr algn="ctr"/>
-            <a:endParaRPr/>
           </a:p>
         </p:txBody>
       </p:sp>
@@ -11071,7 +10900,6 @@
           <a:lstStyle/>
           <a:p>
             <a:pPr algn="ctr"/>
-            <a:endParaRPr/>
           </a:p>
         </p:txBody>
       </p:sp>

</xml_diff>

<commit_message>
docs: cap nhat bao cao + slide theo luong upload per-file va kiem tra trung 2 lop
</commit_message>
<xml_diff>
--- a/LeHongLinh_Slides.pptx
+++ b/LeHongLinh_Slides.pptx
@@ -4312,7 +4312,7 @@
                 </a:solidFill>
                 <a:latin typeface="Arial"/>
               </a:rPr>
-              <a:t>▸ Chia sẻ Công khai / Riêng tư</a:t>
+              <a:t>▸ Chia sẻ Công khai / Riêng tư từng file</a:t>
             </a:r>
           </a:p>
           <a:p>
@@ -4331,7 +4331,7 @@
                 </a:solidFill>
                 <a:latin typeface="Arial"/>
               </a:rPr>
-              <a:t>   Tài liệu công khai: mọi ví đã đăng nhập được server cấp lại khóa và xem trực tiếp. Tài liệu riêng tư: chỉ chủ sở hữu và Admin được cấp khóa, người khác chỉ thấy metadata.</a:t>
+              <a:t>   Chế độ hiển thị và khóa AES đặt riêng cho từng file trong cùng một lô. Tài liệu công khai: mọi ví đã đăng nhập được server cấp lại khóa và xem trực tiếp. Tài liệu riêng tư: chỉ chủ sở hữu và Admin được cấp khóa, người khác chỉ thấy metadata.</a:t>
             </a:r>
           </a:p>
           <a:p>
@@ -4347,7 +4347,7 @@
                 </a:solidFill>
                 <a:latin typeface="Arial"/>
               </a:rPr>
-              <a:t>▸ Cảnh báo upload trùng</a:t>
+              <a:t>▸ Kiểm soát trùng nội dung hai lớp</a:t>
             </a:r>
           </a:p>
           <a:p>
@@ -4366,7 +4366,7 @@
                 </a:solidFill>
                 <a:latin typeface="Arial"/>
               </a:rPr>
-              <a:t>   Trước khi ghi chuỗi, hệ thống so sánh hash file với các bản ghi hiện có và cảnh báo kèm mã tài liệu cũ — người dùng quyết định có tiếp tục hay không.</a:t>
+              <a:t>   Bảng phân loại trước khi nhập khóa: mục "đã thu hồi" cho tải lại, mục "đang hoạt động" cho ghi thêm bản ghi — mỗi dòng hiện ví và thời điểm đóng dấu on-chain. Lớp kiểm tra lần cuối còn bắt trường hợp nội dung vừa được đóng dấu sau khi quét.</a:t>
             </a:r>
           </a:p>
           <a:p>
@@ -5452,7 +5452,7 @@
                 </a:solidFill>
                 <a:latin typeface="Arial"/>
               </a:rPr>
-              <a:t>Kéo-thả tài liệu — chọn chế độ Công khai/Riêng tư, nhập khóa AES</a:t>
+              <a:t>Kéo-thả nhiều tài liệu — bảng phân loại trùng trước, rồi đặt chế độ và khóa AES riêng cho từng file</a:t>
             </a:r>
           </a:p>
         </p:txBody>
@@ -10453,8 +10453,8 @@
                 </a:solidFill>
                 <a:latin typeface="Arial"/>
               </a:rPr>
-              <a:t>Băm SHA-256
-nội dung gốc</a:t>
+              <a:t>Quét trùng
+sổ cái on-chain</a:t>
             </a:r>
           </a:p>
         </p:txBody>
@@ -10553,8 +10553,9 @@
                 </a:solidFill>
                 <a:latin typeface="Arial"/>
               </a:rPr>
-              <a:t>Nhập khóa
-AES-256</a:t>
+              <a:t>Khóa AES +
+chế độ
+từng file</a:t>
             </a:r>
           </a:p>
         </p:txBody>
@@ -10653,8 +10654,8 @@
                 </a:solidFill>
                 <a:latin typeface="Arial"/>
               </a:rPr>
-              <a:t>Mã hóa
-toàn bộ file</a:t>
+              <a:t>Băm SHA-256
++ mã hóa file</a:t>
             </a:r>
           </a:p>
         </p:txBody>
@@ -11001,7 +11002,19 @@
                 </a:solidFill>
                 <a:latin typeface="Arial"/>
               </a:rPr>
-              <a:t>• Trước khi upload, hệ thống đối chiếu hash của file với sổ cái — nếu nội dung đã từng được đóng dấu, người dùng được cảnh báo để tránh ghi trùng tốn phí gas.</a:t>
+              <a:t>• Trước khi nhập khóa, hệ thống đối chiếu hash từng file với sổ cái — bảng phân loại hiển thị ví và thời điểm đã đóng dấu: tài liệu đã thu hồi cho phép tải lại, tài liệu đang hoạt động chỉ tạo thêm bản ghi mới, không bao giờ ghi đè.</a:t>
+            </a:r>
+          </a:p>
+          <a:p>
+            <a:pPr algn="l"/>
+            <a:r>
+              <a:rPr sz="1400" b="0" i="0">
+                <a:solidFill>
+                  <a:srgbClr val="C9D8E4"/>
+                </a:solidFill>
+                <a:latin typeface="Arial"/>
+              </a:rPr>
+              <a:t>• Popup bảo mật liệt kê rõ từng tệp được duyệt: một khóa AES chung cho cả lô, và mỗi file có thể đổi chế độ Công khai/Riêng tư hoặc đặt khóa riêng.</a:t>
             </a:r>
           </a:p>
           <a:p>

</xml_diff>

<commit_message>
docs: rebuild slide chinh thuc voi trang dong gop noi bat
</commit_message>
<xml_diff>
--- a/LeHongLinh_Slides.pptx
+++ b/LeHongLinh_Slides.pptx
@@ -4542,7 +4542,7 @@
                 </a:solidFill>
                 <a:latin typeface="Arial"/>
               </a:rPr>
-              <a:t>05. KẾT QUẢ NGHIÊN CỨU</a:t>
+              <a:t>05. KẾT QUẢ NGHIÊN CỨU — ĐÓNG GÓP NỔI BẬT</a:t>
             </a:r>
           </a:p>
         </p:txBody>
@@ -4634,8 +4634,8 @@
         </p:nvSpPr>
         <p:spPr>
           <a:xfrm>
-            <a:off x="800000" y="1500000"/>
-            <a:ext cx="2400000" cy="1500000"/>
+            <a:off x="700000" y="1450000"/>
+            <a:ext cx="5300000" cy="2250000"/>
           </a:xfrm>
           <a:prstGeom prst="roundRect">
             <a:avLst/>
@@ -4665,22 +4665,38 @@
           </a:fontRef>
         </p:style>
         <p:txBody>
-          <a:bodyPr rtlCol="0" anchor="ctr"/>
+          <a:bodyPr rtlCol="0" anchor="ctr" wrap="square" lIns="220000" rIns="220000" tIns="160000"/>
           <a:lstStyle/>
           <a:p>
             <a:pPr algn="ctr"/>
             <a:r>
-              <a:rPr sz="4000" b="1">
+              <a:rPr sz="1600" b="1">
                 <a:solidFill>
                   <a:srgbClr val="E97132"/>
                 </a:solidFill>
                 <a:latin typeface="Arial"/>
               </a:rPr>
-              <a:t>2</a:t>
-            </a:r>
-          </a:p>
-          <a:p>
-            <a:pPr algn="ctr"/>
+              <a:t>01  </a:t>
+            </a:r>
+            <a:r>
+              <a:rPr sz="1500" b="1">
+                <a:solidFill>
+                  <a:srgbClr val="FFFFFF"/>
+                </a:solidFill>
+                <a:latin typeface="Arial"/>
+              </a:rPr>
+              <a:t>Hệ thống hoàn chỉnh trên môi trường thật</a:t>
+            </a:r>
+          </a:p>
+          <a:p>
+            <a:pPr>
+              <a:lnSpc>
+                <a:spcPct val="120000"/>
+              </a:lnSpc>
+              <a:spcBef>
+                <a:spcPts val="800"/>
+              </a:spcBef>
+            </a:pPr>
             <a:r>
               <a:rPr sz="1200">
                 <a:solidFill>
@@ -4688,8 +4704,7 @@
                 </a:solidFill>
                 <a:latin typeface="Arial"/>
               </a:rPr>
-              <a:t>Smart Contract
-đã triển khai trên Sepolia</a:t>
+              <a:t>Toàn bộ vòng đời tài liệu — đóng dấu, kiểm chứng, thu hồi — vận hành 24/7 trên Sepolia + IPFS; mọi giao dịch tra công khai trên Etherscan.</a:t>
             </a:r>
           </a:p>
         </p:txBody>
@@ -4702,8 +4717,8 @@
         </p:nvSpPr>
         <p:spPr>
           <a:xfrm>
-            <a:off x="3500000" y="1500000"/>
-            <a:ext cx="2400000" cy="1500000"/>
+            <a:off x="6200000" y="1450000"/>
+            <a:ext cx="5300000" cy="2250000"/>
           </a:xfrm>
           <a:prstGeom prst="roundRect">
             <a:avLst/>
@@ -4733,22 +4748,38 @@
           </a:fontRef>
         </p:style>
         <p:txBody>
-          <a:bodyPr rtlCol="0" anchor="ctr"/>
+          <a:bodyPr rtlCol="0" anchor="ctr" wrap="square" lIns="220000" rIns="220000" tIns="160000"/>
           <a:lstStyle/>
           <a:p>
             <a:pPr algn="ctr"/>
             <a:r>
-              <a:rPr sz="4000" b="1">
+              <a:rPr sz="1600" b="1">
                 <a:solidFill>
                   <a:srgbClr val="E97132"/>
                 </a:solidFill>
                 <a:latin typeface="Arial"/>
               </a:rPr>
-              <a:t>117</a:t>
-            </a:r>
-          </a:p>
-          <a:p>
-            <a:pPr algn="ctr"/>
+              <a:t>02  </a:t>
+            </a:r>
+            <a:r>
+              <a:rPr sz="1500" b="1">
+                <a:solidFill>
+                  <a:srgbClr val="FFFFFF"/>
+                </a:solidFill>
+                <a:latin typeface="Arial"/>
+              </a:rPr>
+              <a:t>Kiến trúc hash on-chain, nội dung off-chain</a:t>
+            </a:r>
+          </a:p>
+          <a:p>
+            <a:pPr>
+              <a:lnSpc>
+                <a:spcPct val="120000"/>
+              </a:lnSpc>
+              <a:spcBef>
+                <a:spcPts val="800"/>
+              </a:spcBef>
+            </a:pPr>
             <a:r>
               <a:rPr sz="1200">
                 <a:solidFill>
@@ -4756,8 +4787,7 @@
                 </a:solidFill>
                 <a:latin typeface="Arial"/>
               </a:rPr>
-              <a:t>Test tự động
-79 unit + 38 e2e đều đạt</a:t>
+              <a:t>SHA-256 và quyền RBAC trong Smart Contract; nội dung AES-256 trên IPFS; khóa ủy thác bọc AES-256-GCM — tách rõ phần công khai và phần bảo mật.</a:t>
             </a:r>
           </a:p>
         </p:txBody>
@@ -4770,8 +4800,8 @@
         </p:nvSpPr>
         <p:spPr>
           <a:xfrm>
-            <a:off x="6200000" y="1500000"/>
-            <a:ext cx="2400000" cy="1500000"/>
+            <a:off x="700000" y="3900000"/>
+            <a:ext cx="5300000" cy="2250000"/>
           </a:xfrm>
           <a:prstGeom prst="roundRect">
             <a:avLst/>
@@ -4801,22 +4831,38 @@
           </a:fontRef>
         </p:style>
         <p:txBody>
-          <a:bodyPr rtlCol="0" anchor="ctr"/>
+          <a:bodyPr rtlCol="0" anchor="ctr" wrap="square" lIns="220000" rIns="220000" tIns="160000"/>
           <a:lstStyle/>
           <a:p>
             <a:pPr algn="ctr"/>
             <a:r>
-              <a:rPr sz="4000" b="1">
+              <a:rPr sz="1600" b="1">
                 <a:solidFill>
                   <a:srgbClr val="E97132"/>
                 </a:solidFill>
                 <a:latin typeface="Arial"/>
               </a:rPr>
-              <a:t>24/7</a:t>
-            </a:r>
-          </a:p>
-          <a:p>
-            <a:pPr algn="ctr"/>
+              <a:t>03  </a:t>
+            </a:r>
+            <a:r>
+              <a:rPr sz="1500" b="1">
+                <a:solidFill>
+                  <a:srgbClr val="FFFFFF"/>
+                </a:solidFill>
+                <a:latin typeface="Arial"/>
+              </a:rPr>
+              <a:t>Xác thực không mật khẩu</a:t>
+            </a:r>
+          </a:p>
+          <a:p>
+            <a:pPr>
+              <a:lnSpc>
+                <a:spcPct val="120000"/>
+              </a:lnSpc>
+              <a:spcBef>
+                <a:spcPts val="800"/>
+              </a:spcBef>
+            </a:pPr>
             <a:r>
               <a:rPr sz="1200">
                 <a:solidFill>
@@ -4824,8 +4870,7 @@
                 </a:solidFill>
                 <a:latin typeface="Arial"/>
               </a:rPr>
-              <a:t>Vận hành thực tế
-Render · Atlas · Pinata</a:t>
+              <a:t>Đăng nhập bằng chữ ký ví MetaMask, phiên JWT theo thiết bị, duyệt máy lạ và OTP email — loại bỏ hoàn toàn rủi ro rò rỉ mật khẩu truyền thống.</a:t>
             </a:r>
           </a:p>
         </p:txBody>
@@ -4838,8 +4883,8 @@
         </p:nvSpPr>
         <p:spPr>
           <a:xfrm>
-            <a:off x="8900000" y="1500000"/>
-            <a:ext cx="2400000" cy="1500000"/>
+            <a:off x="6200000" y="3900000"/>
+            <a:ext cx="5300000" cy="2250000"/>
           </a:xfrm>
           <a:prstGeom prst="roundRect">
             <a:avLst/>
@@ -4869,194 +4914,46 @@
           </a:fontRef>
         </p:style>
         <p:txBody>
-          <a:bodyPr rtlCol="0" anchor="ctr"/>
+          <a:bodyPr rtlCol="0" anchor="ctr" wrap="square" lIns="220000" rIns="220000" tIns="160000"/>
           <a:lstStyle/>
           <a:p>
             <a:pPr algn="ctr"/>
             <a:r>
-              <a:rPr sz="4000" b="1">
+              <a:rPr sz="1600" b="1">
                 <a:solidFill>
                   <a:srgbClr val="E97132"/>
                 </a:solidFill>
                 <a:latin typeface="Arial"/>
               </a:rPr>
-              <a:t>4</a:t>
-            </a:r>
-          </a:p>
-          <a:p>
-            <a:pPr algn="ctr"/>
-            <a:r>
-              <a:rPr sz="1200">
-                <a:solidFill>
-                  <a:srgbClr val="C9D8E4"/>
-                </a:solidFill>
-                <a:latin typeface="Arial"/>
-              </a:rPr>
-              <a:t>Vai trò RBAC
-thực thi trong contract</a:t>
-            </a:r>
-          </a:p>
-        </p:txBody>
-      </p:sp>
-      <p:sp>
-        <p:nvSpPr>
-          <p:cNvPr id="11" name="TextBox 10"/>
-          <p:cNvSpPr txBox="1"/>
-          <p:nvPr/>
-        </p:nvSpPr>
-        <p:spPr>
-          <a:xfrm>
-            <a:off x="700000" y="3400000"/>
-            <a:ext cx="10800000" cy="2900000"/>
-          </a:xfrm>
-          <a:prstGeom prst="rect">
-            <a:avLst/>
-          </a:prstGeom>
-          <a:noFill/>
-        </p:spPr>
-        <p:txBody>
-          <a:bodyPr wrap="square">
-            <a:spAutoFit/>
-          </a:bodyPr>
-          <a:lstStyle/>
-          <a:p>
-            <a:pPr>
-              <a:spcAft>
-                <a:spcPts val="800"/>
-              </a:spcAft>
-            </a:pPr>
+              <a:t>04  </a:t>
+            </a:r>
             <a:r>
               <a:rPr sz="1500" b="1">
                 <a:solidFill>
-                  <a:srgbClr val="0F9ED5"/>
-                </a:solidFill>
-                <a:latin typeface="Arial"/>
-              </a:rPr>
-              <a:t>▸ Hệ thống chạy trên môi trường thật</a:t>
+                  <a:srgbClr val="FFFFFF"/>
+                </a:solidFill>
+                <a:latin typeface="Arial"/>
+              </a:rPr>
+              <a:t>Nghiệp vụ đầy đủ, kiểm chứng bằng test tự động</a:t>
             </a:r>
           </a:p>
           <a:p>
             <a:pPr>
               <a:lnSpc>
-                <a:spcPct val="115000"/>
+                <a:spcPct val="120000"/>
               </a:lnSpc>
-              <a:spcAft>
+              <a:spcBef>
                 <a:spcPts val="800"/>
-              </a:spcAft>
+              </a:spcBef>
             </a:pPr>
             <a:r>
-              <a:rPr sz="1300">
+              <a:rPr sz="1200">
                 <a:solidFill>
                   <a:srgbClr val="C9D8E4"/>
                 </a:solidFill>
                 <a:latin typeface="Arial"/>
               </a:rPr>
-              <a:t>   Contract 0xAf1e…dF74 đang hoạt động trên Sepolia; giao diện triển khai tại blockchain-data-integrity.onrender.com. Toàn bộ luồng tải lên — đóng dấu — kiểm chứng — thu hồi đều thao tác trực tiếp được.</a:t>
-            </a:r>
-          </a:p>
-          <a:p>
-            <a:pPr>
-              <a:spcAft>
-                <a:spcPts val="800"/>
-              </a:spcAft>
-            </a:pPr>
-            <a:r>
-              <a:rPr sz="1500" b="1">
-                <a:solidFill>
-                  <a:srgbClr val="0F9ED5"/>
-                </a:solidFill>
-                <a:latin typeface="Arial"/>
-              </a:rPr>
-              <a:t>▸ Phát hiện giả mạo ở mức bit</a:t>
-            </a:r>
-          </a:p>
-          <a:p>
-            <a:pPr>
-              <a:lnSpc>
-                <a:spcPct val="115000"/>
-              </a:lnSpc>
-              <a:spcAft>
-                <a:spcPts val="800"/>
-              </a:spcAft>
-            </a:pPr>
-            <a:r>
-              <a:rPr sz="1300">
-                <a:solidFill>
-                  <a:srgbClr val="C9D8E4"/>
-                </a:solidFill>
-                <a:latin typeface="Arial"/>
-              </a:rPr>
-              <a:t>   Mọi chỉnh sửa dù nhỏ nhất đều bị phát hiện: verify so sánh SHA-256 của file nộp với bản ghi on-chain — đổi một ký tự là đổi toàn bộ dấu vân tay. Tài liệu đã thu hồi được cảnh báo riêng kèm lý do thay vì chỉ báo đúng/sai.</a:t>
-            </a:r>
-          </a:p>
-          <a:p>
-            <a:pPr>
-              <a:spcAft>
-                <a:spcPts val="800"/>
-              </a:spcAft>
-            </a:pPr>
-            <a:r>
-              <a:rPr sz="1500" b="1">
-                <a:solidFill>
-                  <a:srgbClr val="0F9ED5"/>
-                </a:solidFill>
-                <a:latin typeface="Arial"/>
-              </a:rPr>
-              <a:t>▸ Kiến trúc chống mất dữ liệu</a:t>
-            </a:r>
-          </a:p>
-          <a:p>
-            <a:pPr>
-              <a:lnSpc>
-                <a:spcPct val="115000"/>
-              </a:lnSpc>
-              <a:spcAft>
-                <a:spcPts val="800"/>
-              </a:spcAft>
-            </a:pPr>
-            <a:r>
-              <a:rPr sz="1300">
-                <a:solidFill>
-                  <a:srgbClr val="C9D8E4"/>
-                </a:solidFill>
-                <a:latin typeface="Arial"/>
-              </a:rPr>
-              <a:t>   Metadata lưu MongoDB qua endpoint ghi lũy đẳng kèm hàng đợi tự phục hồi phía client; cache sự kiện on-chain chỉ tiến con trỏ trên đoạn quét liền kề nên bản ghi không bao giờ bị bỏ sót.</a:t>
-            </a:r>
-          </a:p>
-          <a:p>
-            <a:pPr>
-              <a:spcAft>
-                <a:spcPts val="800"/>
-              </a:spcAft>
-            </a:pPr>
-            <a:r>
-              <a:rPr sz="1500" b="1">
-                <a:solidFill>
-                  <a:srgbClr val="0F9ED5"/>
-                </a:solidFill>
-                <a:latin typeface="Arial"/>
-              </a:rPr>
-              <a:t>▸ Bảo mật nhiều lớp phối hợp</a:t>
-            </a:r>
-          </a:p>
-          <a:p>
-            <a:pPr>
-              <a:lnSpc>
-                <a:spcPct val="115000"/>
-              </a:lnSpc>
-              <a:spcAft>
-                <a:spcPts val="800"/>
-              </a:spcAft>
-            </a:pPr>
-            <a:r>
-              <a:rPr sz="1300">
-                <a:solidFill>
-                  <a:srgbClr val="C9D8E4"/>
-                </a:solidFill>
-                <a:latin typeface="Arial"/>
-              </a:rPr>
-              <a:t>   Chữ ký ví thay mật khẩu, phiên JWT có thời hạn, duyệt thiết bị từ máy cũ kèm nhận diện IP–trình duyệt, OTP email làm đường cứu, phân quyền ngay trong contract, mã hóa AES-256 phía client và bọc khóa bằng khóa chủ phía server.</a:t>
+              <a:t>Upload lô một lần ký MetaMask, kiểm soát trùng nội dung hai lớp, khóa và chế độ chia sẻ riêng từng file, xem trước DOCX/PDF, API cho đối tác — bao phủ 117 ca test.</a:t>
             </a:r>
           </a:p>
         </p:txBody>

</xml_diff>

<commit_message>
docs: cập nhật báo cáo/slide/phụ lục/README theo thay đổi mới
- Số kiểm thử: 96 ca tự động (80 + 16 backend) và 48 bước e2e
- Mục 2.4.6 vòng đời ví: duyệt — khóa — xóa — khôi phục, chặn 30p
- Wallet collection bổ sung rejected/rejectCount/rejectBlockedUntil
- Phụ lục C thêm file hardening.test.js
- Slide: đóng góp nghiệp vụ + kịch bản demo cập nhật

Generated with [Devin](https://devin.ai)

Co-Authored-By: Devin <158243242+devin-ai-integration[bot]@users.noreply.github.com>
</commit_message>
<xml_diff>
--- a/LeHongLinh_Slides.pptx
+++ b/LeHongLinh_Slides.pptx
@@ -4203,7 +4203,7 @@
                 </a:solidFill>
                 <a:latin typeface="Arial"/>
               </a:rPr>
-              <a:t>   Ba cấp quyền kế thừa lũy tiến NHẬP LIỆU (rank 1) → QUẢN LÝ (rank 2) → ADMIN (rank 3) được lưu và kiểm tra trực tiếp trên contract; vai trò NGƯỜI XEM chỉ đọc bổ sung ở tầng backend. Mọi quyền ghi do chính contract chặn — sửa database cũng không leo thang được quyền.</a:t>
+              <a:t>   Ba cấp quyền kế thừa lũy tiến NHẬP LIỆU (rank 1) → QUẢN LÝ (rank 2) → ADMIN (rank 3) được lưu và kiểm tra trực tiếp trên contract; vai trò NGƯỜI XEM chỉ đọc bổ sung ở tầng backend. Vòng đời ví đầy đủ: duyệt — tạm khóa — mở khóa — xóa — đăng ký lại; ví bị khóa không thể tự mở, từ chối 3 lần chặn xin lại 30 phút. Mọi quyền ghi do chính contract chặn — sửa database cũng không leo thang được quyền.</a:t>
             </a:r>
           </a:p>
           <a:p>
@@ -4347,7 +4347,7 @@
                 </a:solidFill>
                 <a:latin typeface="Arial"/>
               </a:rPr>
-              <a:t>▸ Kiểm soát trùng nội dung hai lớp</a:t>
+              <a:t>▸ Kiểm soát trùng nội dung hai lớp theo ví</a:t>
             </a:r>
           </a:p>
           <a:p>
@@ -4366,7 +4366,7 @@
                 </a:solidFill>
                 <a:latin typeface="Arial"/>
               </a:rPr>
-              <a:t>   Bảng phân loại trước khi nhập khóa: mục "đã thu hồi" cho tải lại, mục "đang hoạt động" cho ghi thêm bản ghi — mỗi dòng hiện ví và thời điểm đóng dấu on-chain. Lớp kiểm tra lần cuối còn bắt trường hợp nội dung vừa được đóng dấu sau khi quét.</a:t>
+              <a:t>   Contract lưu sổ chống trùng riêng cho từng ví (multi-tenant): nội dung trùng của chính ví thì chỉ được bỏ qua, nội dung của ví khác upload bình thường như file mới — mỗi tổ chức giữ bản ghi và khóa riêng. Lớp kiểm tra lần cuối tự loại nội dung vừa được chính ví đóng dấu sau khi quét.</a:t>
             </a:r>
           </a:p>
           <a:p>
@@ -4953,7 +4953,7 @@
                 </a:solidFill>
                 <a:latin typeface="Arial"/>
               </a:rPr>
-              <a:t>Upload lô một lần ký MetaMask, kiểm soát trùng nội dung hai lớp, khóa và chế độ chia sẻ riêng từng file, xem trước DOCX/PDF, API cho đối tác — bao phủ 117 ca test.</a:t>
+              <a:t>Upload lô một lần ký MetaMask, kiểm soát trùng nội dung hai lớp, khóa và chế độ chia sẻ riêng từng file, xem trước DOCX/PDF, API cho đối tác — bao phủ 144 ca kiểm thử (96 tự động + 48 end-to-end).</a:t>
             </a:r>
           </a:p>
         </p:txBody>
@@ -5701,7 +5701,7 @@
                 </a:solidFill>
                 <a:latin typeface="Arial"/>
               </a:rPr>
-              <a:t>Phân quyền: khay chờ duyệt ví mới → cấp vai trò → đối chiếu trên sổ cái</a:t>
+              <a:t>Phân quyền: khay chờ duyệt ví mới → cấp vai trò → khóa/mở khóa ví → đối chiếu trên sổ cái</a:t>
             </a:r>
           </a:p>
         </p:txBody>

</xml_diff>

<commit_message>
Private tuyệt đối + đổi chế độ public↔private sau upload
- Chính sách riêng tư mới: file private CHỈ uploader mở được — bỏ nhánh
  rank>=3 ở GET /documents/:id/key, kể cả ADMIN cũng 403 và thấy nút
  khóa trên file private của ví khác
- POST /api/documents/:docId/visibility: chủ sở hữu đổi chế độ hiển thị
  bất cứ lúc nào (file đã thu hồi → 409, không phải chủ → 403)
- UI: nút "Chế độ" trên dòng file của chính mình trong Truy Xuất,
  popup xác nhận kèm cảnh báo khi chuyển về riêng tư
- E2E +8 ca (đổi chế độ, admin bị chặn khóa/chế độ file người khác)
  → 67/67 pass; unit 80/80; đồng bộ báo cáo/phụ lục/tóm tắt/slide

Generated with [Devin](https://devin.ai)

Co-Authored-By: Devin <158243242+devin-ai-integration[bot]@users.noreply.github.com>
</commit_message>
<xml_diff>
--- a/LeHongLinh_Slides.pptx
+++ b/LeHongLinh_Slides.pptx
@@ -4331,7 +4331,7 @@
                 </a:solidFill>
                 <a:latin typeface="Arial"/>
               </a:rPr>
-              <a:t>   Chế độ hiển thị và khóa AES đặt riêng cho từng file trong cùng một lô. Tài liệu công khai: mọi ví đã đăng nhập được server cấp lại khóa và xem trực tiếp. Tài liệu riêng tư: chỉ chủ sở hữu và Admin được cấp khóa, người khác chỉ thấy metadata.</a:t>
+              <a:t>   Chế độ hiển thị và khóa AES đặt riêng cho từng file trong cùng một lô — chủ sở hữu đổi được chế độ bất cứ lúc nào. Tài liệu công khai: mọi ví đã đăng nhập được server cấp lại khóa và xem trực tiếp. Tài liệu riêng tư: chỉ chủ sở hữu được cấp khóa — kể cả Admin cũng không xem được, người khác chỉ thấy metadata.</a:t>
             </a:r>
           </a:p>
           <a:p>
@@ -4953,7 +4953,7 @@
                 </a:solidFill>
                 <a:latin typeface="Arial"/>
               </a:rPr>
-              <a:t>Upload lô một lần ký MetaMask, kiểm soát trùng nội dung hai lớp, khóa và chế độ chia sẻ riêng từng file, xem trước DOCX/PDF, API cho đối tác — bao phủ 155 ca kiểm thử (96 tự động + 59 end-to-end).</a:t>
+              <a:t>Upload lô một lần ký MetaMask, kiểm soát trùng nội dung hai lớp, khóa và chế độ chia sẻ riêng từng file, xem trước DOCX/PDF, API cho đối tác — bao phủ 163 ca kiểm thử (96 tự động + 67 end-to-end).</a:t>
             </a:r>
           </a:p>
         </p:txBody>

</xml_diff>